<commit_message>
ppt copertina, lie factor =1 non 0! aggiunto refactoring evoluzione temporale con incertezza -> modificata slide finale
</commit_message>
<xml_diff>
--- a/the_shape_of_music.pptx
+++ b/the_shape_of_music.pptx
@@ -4,6 +4,9 @@
   <p:sldMasterIdLst>
     <p:sldMasterId id="2147483648" r:id="rId1"/>
   </p:sldMasterIdLst>
+  <p:notesMasterIdLst>
+    <p:notesMasterId r:id="rId20"/>
+  </p:notesMasterIdLst>
   <p:sldIdLst>
     <p:sldId id="256" r:id="rId2"/>
     <p:sldId id="257" r:id="rId3"/>
@@ -24,10 +27,7 @@
     <p:sldId id="272" r:id="rId18"/>
     <p:sldId id="273" r:id="rId19"/>
   </p:sldIdLst>
-  <p:notesMasterIdLst>
-    <p:notesMasterId r:id="rId20"/>
-  </p:notesMasterIdLst>
-  <p:sldSz cx="9144000" cy="5143500"/>
+  <p:sldSz cx="9144000" cy="5143500" type="screen16x9"/>
   <p:notesSz cx="5143500" cy="9144000"/>
   <p:defaultTextStyle>
     <a:lvl1pPr marL="0" algn="l" defTabSz="914400" rtl="0" eaLnBrk="1" latinLnBrk="0" hangingPunct="1">
@@ -121,6 +121,11 @@
       </a:defRPr>
     </a:lvl9pPr>
   </p:defaultTextStyle>
+  <p:extLst>
+    <p:ext uri="{EFAFB233-063F-42B5-8137-9DF3F51BA10A}">
+      <p15:sldGuideLst xmlns:p15="http://schemas.microsoft.com/office/powerpoint/2012/main"/>
+    </p:ext>
+  </p:extLst>
 </p:presentation>
 </file>
 
@@ -146,234 +151,10 @@
           <a:chExt cx="0" cy="0"/>
         </a:xfrm>
       </p:grpSpPr>
-      <p:sp>
-        <p:nvSpPr>
-          <p:cNvPr id="2" name="Header Placeholder 1"/>
-          <p:cNvSpPr>
-            <a:spLocks noGrp="1"/>
-          </p:cNvSpPr>
-          <p:nvPr>
-            <p:ph type="hdr" sz="quarter"/>
-          </p:nvPr>
-        </p:nvSpPr>
-        <p:spPr>
-          <a:xfrm>
-            <a:off x="0" y="0"/>
-            <a:ext cx="2971800" cy="458788"/>
-          </a:xfrm>
-          <a:prstGeom prst="rect">
-            <a:avLst/>
-          </a:prstGeom>
-        </p:spPr>
-        <p:txBody>
-          <a:bodyPr vert="horz" lIns="91440" tIns="45720" rIns="91440" bIns="45720" rtlCol="0"/>
-          <a:lstStyle>
-            <a:lvl1pPr algn="l">
-              <a:defRPr sz="1200"/>
-            </a:lvl1pPr>
-          </a:lstStyle>
-          <a:p>
-            <a:endParaRPr lang="en-US"/>
-          </a:p>
-        </p:txBody>
-      </p:sp>
-      <p:sp>
-        <p:nvSpPr>
-          <p:cNvPr id="3" name="Date Placeholder 2"/>
-          <p:cNvSpPr>
-            <a:spLocks noGrp="1"/>
-          </p:cNvSpPr>
-          <p:nvPr>
-            <p:ph type="dt" idx="1"/>
-          </p:nvPr>
-        </p:nvSpPr>
-        <p:spPr>
-          <a:xfrm>
-            <a:off x="3884613" y="0"/>
-            <a:ext cx="2971800" cy="458788"/>
-          </a:xfrm>
-          <a:prstGeom prst="rect">
-            <a:avLst/>
-          </a:prstGeom>
-        </p:spPr>
-        <p:txBody>
-          <a:bodyPr vert="horz" lIns="91440" tIns="45720" rIns="91440" bIns="45720" rtlCol="0"/>
-          <a:lstStyle>
-            <a:lvl1pPr algn="r">
-              <a:defRPr sz="1200"/>
-            </a:lvl1pPr>
-          </a:lstStyle>
-          <a:p>
-            <a:fld id="{5282F153-3F37-0F45-9E97-73ACFA13230C}" type="datetimeFigureOut">
-              <a:rPr lang="en-US"/>
-              <a:t>7/23/19</a:t>
-            </a:fld>
-            <a:endParaRPr lang="en-US"/>
-          </a:p>
-        </p:txBody>
-      </p:sp>
-      <p:sp>
-        <p:nvSpPr>
-          <p:cNvPr id="4" name="Slide Image Placeholder 3"/>
-          <p:cNvSpPr>
-            <a:spLocks noGrp="1" noRot="1" noChangeAspect="1"/>
-          </p:cNvSpPr>
-          <p:nvPr>
-            <p:ph type="sldImg" idx="2"/>
-          </p:nvPr>
-        </p:nvSpPr>
-        <p:spPr>
-          <a:xfrm>
-            <a:off x="685800" y="1143000"/>
-            <a:ext cx="5486400" cy="3086100"/>
-          </a:xfrm>
-          <a:prstGeom prst="rect">
-            <a:avLst/>
-          </a:prstGeom>
-          <a:noFill/>
-          <a:ln w="12700">
-            <a:solidFill>
-              <a:prstClr val="black"/>
-            </a:solidFill>
-          </a:ln>
-        </p:spPr>
-        <p:txBody>
-          <a:bodyPr vert="horz" lIns="91440" tIns="45720" rIns="91440" bIns="45720" rtlCol="0" anchor="ctr"/>
-          <a:lstStyle/>
-          <a:p>
-            <a:endParaRPr lang="en-US"/>
-          </a:p>
-        </p:txBody>
-      </p:sp>
-      <p:sp>
-        <p:nvSpPr>
-          <p:cNvPr id="5" name="Notes Placeholder 4"/>
-          <p:cNvSpPr>
-            <a:spLocks noGrp="1"/>
-          </p:cNvSpPr>
-          <p:nvPr>
-            <p:ph type="body" sz="quarter" idx="3"/>
-          </p:nvPr>
-        </p:nvSpPr>
-        <p:spPr>
-          <a:xfrm>
-            <a:off x="685800" y="4400550"/>
-            <a:ext cx="5486400" cy="3600450"/>
-          </a:xfrm>
-          <a:prstGeom prst="rect">
-            <a:avLst/>
-          </a:prstGeom>
-        </p:spPr>
-        <p:txBody>
-          <a:bodyPr vert="horz" lIns="91440" tIns="45720" rIns="91440" bIns="45720" rtlCol="0"/>
-          <a:lstStyle/>
-          <a:p>
-            <a:pPr lvl="0"/>
-            <a:r>
-              <a:rPr lang="en-US"/>
-              <a:t>Click to edit Master text styles</a:t>
-            </a:r>
-          </a:p>
-          <a:p>
-            <a:pPr lvl="1"/>
-            <a:r>
-              <a:rPr lang="en-US"/>
-              <a:t>Second level</a:t>
-            </a:r>
-          </a:p>
-          <a:p>
-            <a:pPr lvl="2"/>
-            <a:r>
-              <a:rPr lang="en-US"/>
-              <a:t>Third level</a:t>
-            </a:r>
-          </a:p>
-          <a:p>
-            <a:pPr lvl="3"/>
-            <a:r>
-              <a:rPr lang="en-US"/>
-              <a:t>Fourth level</a:t>
-            </a:r>
-          </a:p>
-          <a:p>
-            <a:pPr lvl="4"/>
-            <a:r>
-              <a:rPr lang="en-US"/>
-              <a:t>Fifth level</a:t>
-            </a:r>
-          </a:p>
-        </p:txBody>
-      </p:sp>
-      <p:sp>
-        <p:nvSpPr>
-          <p:cNvPr id="6" name="Footer Placeholder 5"/>
-          <p:cNvSpPr>
-            <a:spLocks noGrp="1"/>
-          </p:cNvSpPr>
-          <p:nvPr>
-            <p:ph type="ftr" sz="quarter" idx="4"/>
-          </p:nvPr>
-        </p:nvSpPr>
-        <p:spPr>
-          <a:xfrm>
-            <a:off x="0" y="8685213"/>
-            <a:ext cx="2971800" cy="458787"/>
-          </a:xfrm>
-          <a:prstGeom prst="rect">
-            <a:avLst/>
-          </a:prstGeom>
-        </p:spPr>
-        <p:txBody>
-          <a:bodyPr vert="horz" lIns="91440" tIns="45720" rIns="91440" bIns="45720" rtlCol="0" anchor="b"/>
-          <a:lstStyle>
-            <a:lvl1pPr algn="l">
-              <a:defRPr sz="1200"/>
-            </a:lvl1pPr>
-          </a:lstStyle>
-          <a:p>
-            <a:endParaRPr lang="en-US"/>
-          </a:p>
-        </p:txBody>
-      </p:sp>
-      <p:sp>
-        <p:nvSpPr>
-          <p:cNvPr id="7" name="Slide Number Placeholder 6"/>
-          <p:cNvSpPr>
-            <a:spLocks noGrp="1"/>
-          </p:cNvSpPr>
-          <p:nvPr>
-            <p:ph type="sldNum" sz="quarter" idx="5"/>
-          </p:nvPr>
-        </p:nvSpPr>
-        <p:spPr>
-          <a:xfrm>
-            <a:off x="3884613" y="8685213"/>
-            <a:ext cx="2971800" cy="458787"/>
-          </a:xfrm>
-          <a:prstGeom prst="rect">
-            <a:avLst/>
-          </a:prstGeom>
-        </p:spPr>
-        <p:txBody>
-          <a:bodyPr vert="horz" lIns="91440" tIns="45720" rIns="91440" bIns="45720" rtlCol="0" anchor="b"/>
-          <a:lstStyle>
-            <a:lvl1pPr algn="r">
-              <a:defRPr sz="1200"/>
-            </a:lvl1pPr>
-          </a:lstStyle>
-          <a:p>
-            <a:fld id="{CE5E9CC1-C706-0F49-92D6-E571CC5EEA8F}" type="slidenum">
-              <a:rPr lang="en-US"/>
-              <a:t>‹#›</a:t>
-            </a:fld>
-            <a:endParaRPr lang="en-US"/>
-          </a:p>
-        </p:txBody>
-      </p:sp>
     </p:spTree>
     <p:extLst>
       <p:ext uri="{BB962C8B-B14F-4D97-AF65-F5344CB8AC3E}">
-        <p14:creationId xmlns:p14="http://schemas.microsoft.com/office/powerpoint/2010/main" val="1024086991"/>
+        <p14:creationId xmlns:p14="http://schemas.microsoft.com/office/powerpoint/2010/main" val="2107056875"/>
       </p:ext>
     </p:extLst>
   </p:cSld>
@@ -521,7 +302,6 @@
               <a:rPr lang="en-US" dirty="0"/>
               <a:t>Aprire con la domanda narrativa: se potessimo ascoltare un decennio in pochi secondi, come suonerebbe? Il titolo rimanda sia alla forma visiva dei grafici — line plot, parallel coordinates — che al profilo sonoro di ogni epoca. Il dataset Kaggle di Yamac Eren Ay e tra i rari con 100 anni di copertura e feature audio normalizzate dall'API Spotify.</a:t>
             </a:r>
-            <a:endParaRPr lang="en-US" dirty="0"/>
           </a:p>
         </p:txBody>
       </p:sp>
@@ -609,7 +389,6 @@
               <a:rPr lang="en-US" dirty="0"/>
               <a:t>K-Means trova i cluster SENZA etichette di genere. Poi confrontiamo con i generi reali.</a:t>
             </a:r>
-            <a:endParaRPr lang="en-US" dirty="0"/>
           </a:p>
         </p:txBody>
       </p:sp>
@@ -697,7 +476,6 @@
               <a:rPr lang="en-US" dirty="0"/>
               <a:t>La scelta di k non è arbitraria: è giustificata da due metriche indipendenti. Il Silhouette Score misura quanto un punto è simile al suo cluster rispetto agli altri. Il k evidenziato in arancione bruciato è immediatamente identificabile senza leggere i valori numerici (Ware: pre-attentività).</a:t>
             </a:r>
-            <a:endParaRPr lang="en-US" dirty="0"/>
           </a:p>
         </p:txBody>
       </p:sp>
@@ -785,7 +563,6 @@
               <a:rPr lang="en-US" dirty="0"/>
               <a:t>Ogni linea spessa è un cluster = un archetipo sonoro. Le linee sottili in background mostrano la densità reale dei dati. Il nome di ogni cluster (es. 'acustico-calmo') è stato assegnato a posteriori leggendo il profilo Z-score — l'algoritmo non conosceva le etichette. NOTA CRITICA: un Parallel Coordinates Plot statico su dati ad alta densità è un anti-pattern (Shneiderman) senza brushing interattivo. Per il 30L si implementerebbe in Plotly con filtering dinamico.</a:t>
             </a:r>
-            <a:endParaRPr lang="en-US" dirty="0"/>
           </a:p>
         </p:txBody>
       </p:sp>
@@ -873,7 +650,6 @@
               <a:rPr lang="en-US" dirty="0"/>
               <a:t>La domanda più narrativamente forte del progetto. Spoiler: non è solo la danceability.</a:t>
             </a:r>
-            <a:endParaRPr lang="en-US" dirty="0"/>
           </a:p>
         </p:txBody>
       </p:sp>
@@ -961,7 +737,6 @@
               <a:rPr lang="en-US" dirty="0"/>
               <a:t>Random Forest sarebbe più accurato, ma un Decision Tree singolo è l'unico modello che si può VISUALIZZARE — requisito del modulo Soto. Leggere l'albero in live: 'Prima domanda: energy &gt; X? Sì → vai a destra, la canzone ha più probabilità di essere una hit.' Seguire il path più interessante per la narrativa. MIGLIORAMENTO POSSIBILE: mappare lo spessore dei rami proporzionalmente al numero di sample che li attraversano (Soto: visual variable thickness).</a:t>
             </a:r>
-            <a:endParaRPr lang="en-US" dirty="0"/>
           </a:p>
         </p:txBody>
       </p:sp>
@@ -1049,7 +824,6 @@
               <a:rPr lang="en-US" dirty="0"/>
               <a:t>Compilare i valori della tabella dopo aver eseguito il notebook. Il punto chiave: quale feature emerge come split principale alla radice? Questo risponde alla domanda di ricerca 'formula del successo'. La Confusion Matrix mostra onestamente il trade-off: class_weight='balanced' aiuta ma non risolve lo sbilanciamento hit/non-hit.</a:t>
             </a:r>
-            <a:endParaRPr lang="en-US" dirty="0"/>
           </a:p>
         </p:txBody>
       </p:sp>
@@ -1137,7 +911,6 @@
               <a:rPr lang="en-US" dirty="0"/>
               <a:t>Rispondere a ciascuna domanda con i valori REALI dal notebook. Collegare le risposte: acousticness cala (M2) → questo separa i cluster (M4) → l'energy alta predice le hit (M5). Il filo narrativo è una storia unica, non tre analisi separate.</a:t>
             </a:r>
-            <a:endParaRPr lang="en-US" dirty="0"/>
           </a:p>
         </p:txBody>
       </p:sp>
@@ -1225,7 +998,6 @@
               <a:rPr lang="en-US" dirty="0"/>
               <a:t>Dichiarare i limiti prima che la commissione li sollevi: è un segnale di rigore metodologico, non di debolezza.</a:t>
             </a:r>
-            <a:endParaRPr lang="en-US" dirty="0"/>
           </a:p>
         </p:txBody>
       </p:sp>
@@ -1309,10 +1081,6 @@
           <a:bodyPr/>
           <a:lstStyle/>
           <a:p>
-            <a:r>
-              <a:rPr lang="en-US" dirty="0"/>
-              <a:t/>
-            </a:r>
             <a:endParaRPr lang="en-US" dirty="0"/>
           </a:p>
         </p:txBody>
@@ -1401,7 +1169,6 @@
               <a:rPr lang="en-US" dirty="0"/>
               <a:t>Risponde alla criticità del Nested Model (Munzner). WHY = perché visualizzare → gli obiettivi analitici. WHAT = cosa visualizzare → tipo di attributi nei dati. HOW = come visualizzare → la scelta dell'idiom visivo. Ogni livello ha le sue minacce alla validità: spiegare brevemente.</a:t>
             </a:r>
-            <a:endParaRPr lang="en-US" dirty="0"/>
           </a:p>
         </p:txBody>
       </p:sp>
@@ -1489,7 +1256,6 @@
               <a:rPr lang="en-US" dirty="0"/>
               <a:t>La tabella Tab.1 (da mostrare in backup) applica Few: solo le misure necessarie, niente decorazione. La colonna null_% è evidenziata solo dove &gt; 0 (ombreggiatura come segnale, non come ornamento). Il grafico mostra la distribuzione dei macro-generi estratti da artists.csv: citare la presenza di 'Other' e motivarla.</a:t>
             </a:r>
-            <a:endParaRPr lang="en-US" dirty="0"/>
           </a:p>
         </p:txBody>
       </p:sp>
@@ -1577,7 +1343,6 @@
               <a:rPr lang="en-US" dirty="0"/>
               <a:t>Sezione di transizione. La domanda aperta crea attesa: lasciarla sospesa un secondo prima di far vedere il grafico.</a:t>
             </a:r>
-            <a:endParaRPr lang="en-US" dirty="0"/>
           </a:p>
         </p:txBody>
       </p:sp>
@@ -1665,7 +1430,6 @@
               <a:rPr lang="en-US" dirty="0"/>
               <a:t>Spiegare perché si vede immediatamente l'arancione senza leggere la legenda: questo è l'attributo pre-attentivo di Ware. La legenda esterna è stata eliminata perché aggiunge carico cognitivo (working memory). NOTA CRITICA: in una versione migliorata (30L) si aggiungerebbe una fascia fill_between che mostra la varianza attorno alla media — l'assenza di intervalli di confidenza è una limitazione dichiarata.</a:t>
             </a:r>
-            <a:endParaRPr lang="en-US" dirty="0"/>
           </a:p>
         </p:txBody>
       </p:sp>
@@ -1753,7 +1517,6 @@
               <a:rPr lang="en-US" dirty="0"/>
               <a:t>La heatmap complementa il line plot: là vediamo la forma del trend, qui i valori precisi per decade. La scala RdBu_r è stata scelta al posto di RdYlGn (originale) perché RdYlGn non è distinguibile per i daltonici rosso-verdi (~8% degli uomini). Il valore numerico in ogni cella risponde al principio di ridondanza percettiva di Ware: il colore da solo non basta, il numero è il failsafe.</a:t>
             </a:r>
-            <a:endParaRPr lang="en-US" dirty="0"/>
           </a:p>
         </p:txBody>
       </p:sp>
@@ -1841,7 +1604,6 @@
               <a:rPr lang="en-US" dirty="0"/>
               <a:t>Problema da risolvere: se metto tutte le linee in un unico plot ottengo effetto spaghetti. La soluzione è la griglia Tufte.</a:t>
             </a:r>
-            <a:endParaRPr lang="en-US" dirty="0"/>
           </a:p>
         </p:txBody>
       </p:sp>
@@ -1929,7 +1691,6 @@
               <a:rPr lang="en-US" dirty="0"/>
               <a:t>Principio Tufte: stessa scala (sharey=True), stesso frame visivo per ogni pannello. L'occhio confronta le FORME, non le scale. I generi sono ordinati per numerosità campionaria (più frequente a sinistra) come prescrive Bertin: i dati nominali senza ordine intrinseco vanno ordinati per una metrica derivata dai dati stessi. Classical mantiene acousticness alta e stabile → musica acustica per definizione. Electronic crolla → transizione tecnologica visibile.</a:t>
             </a:r>
-            <a:endParaRPr lang="en-US" dirty="0"/>
           </a:p>
         </p:txBody>
       </p:sp>
@@ -2017,7 +1778,6 @@
               <a:rPr lang="en-US" dirty="0"/>
               <a:t>La versione estesa 4×5 permette di vedere tutti i pattern insieme. sharey='row' significa che la scala di danceability è la stessa per tutti i generi NELLA STESSA RIGA — le differenze visibili sono differenze reali nei dati. Nota: Hip-Hop mostra la danceability in crescita costante dopo il 1990 — questo emerge immediatamente dalla forma del pannello, non serve testo.</a:t>
             </a:r>
-            <a:endParaRPr lang="en-US" dirty="0"/>
           </a:p>
         </p:txBody>
       </p:sp>
@@ -2090,6 +1850,11 @@
 <file path=ppt/slideMasters/slideMaster1.xml><?xml version="1.0" encoding="utf-8"?>
 <p:sldMaster xmlns:a="http://schemas.openxmlformats.org/drawingml/2006/main" xmlns:r="http://schemas.openxmlformats.org/officeDocument/2006/relationships" xmlns:p="http://schemas.openxmlformats.org/presentationml/2006/main">
   <p:cSld>
+    <p:bg>
+      <p:bgRef idx="1001">
+        <a:schemeClr val="bg1"/>
+      </p:bgRef>
+    </p:bg>
     <p:spTree>
       <p:nvGrpSpPr>
         <p:cNvPr id="1" name=""/>
@@ -2372,6 +2137,7 @@
         <a:solidFill>
           <a:srgbClr val="2C2C2A"/>
         </a:solidFill>
+        <a:effectLst/>
       </p:bgPr>
     </p:bg>
     <p:spTree>
@@ -2396,7 +2162,7 @@
         </p:nvSpPr>
         <p:spPr>
           <a:xfrm>
-            <a:off x="4754880" y="2560320"/>
+            <a:off x="4282745" y="2030562"/>
             <a:ext cx="4389120" cy="2011680"/>
           </a:xfrm>
           <a:prstGeom prst="rect">
@@ -2409,99 +2175,171 @@
           <a:bodyPr wrap="square" rtlCol="0" anchor="ctr"/>
           <a:lstStyle/>
           <a:p>
-            <a:pPr algn="r" indent="0" marL="0">
+            <a:pPr marL="0" indent="0" algn="r">
               <a:buNone/>
             </a:pPr>
             <a:r>
               <a:rPr lang="en-US" sz="8000" b="1" dirty="0">
                 <a:solidFill>
-                  <a:srgbClr val="3C3C3A"/>
+                  <a:srgbClr val="C05200"/>
                 </a:solidFill>
                 <a:latin typeface="Cambria" pitchFamily="34" charset="0"/>
                 <a:ea typeface="Cambria" pitchFamily="34" charset="-122"/>
                 <a:cs typeface="Cambria" pitchFamily="34" charset="-120"/>
               </a:rPr>
-              <a:t>1921–2020</a:t>
-            </a:r>
-            <a:endParaRPr lang="en-US" sz="8000" dirty="0"/>
-          </a:p>
-        </p:txBody>
-      </p:sp>
-      <p:sp>
-        <p:nvSpPr>
-          <p:cNvPr id="3" name="Text 1"/>
-          <p:cNvSpPr/>
-          <p:nvPr/>
-        </p:nvSpPr>
-        <p:spPr>
-          <a:xfrm>
-            <a:off x="502920" y="822960"/>
-            <a:ext cx="6400800" cy="914400"/>
-          </a:xfrm>
-          <a:prstGeom prst="rect">
-            <a:avLst/>
-          </a:prstGeom>
-          <a:noFill/>
-          <a:ln/>
-        </p:spPr>
-        <p:txBody>
-          <a:bodyPr wrap="square" rtlCol="0" anchor="ctr"/>
-          <a:lstStyle/>
-          <a:p>
-            <a:pPr indent="0" marL="0">
-              <a:buNone/>
-            </a:pPr>
-            <a:r>
-              <a:rPr lang="en-US" sz="5200" b="1" dirty="0">
-                <a:solidFill>
-                  <a:srgbClr val="FAFAF8"/>
+              <a:t>19</a:t>
+            </a:r>
+            <a:r>
+              <a:rPr lang="en-US" sz="8000" b="1" dirty="0">
+                <a:solidFill>
+                  <a:srgbClr val="3C3C3A"/>
                 </a:solidFill>
                 <a:latin typeface="Cambria" pitchFamily="34" charset="0"/>
                 <a:ea typeface="Cambria" pitchFamily="34" charset="-122"/>
                 <a:cs typeface="Cambria" pitchFamily="34" charset="-120"/>
               </a:rPr>
-              <a:t>The Shape</a:t>
-            </a:r>
-            <a:endParaRPr lang="en-US" sz="5200" dirty="0"/>
-          </a:p>
-        </p:txBody>
-      </p:sp>
-      <p:sp>
-        <p:nvSpPr>
-          <p:cNvPr id="4" name="Text 2"/>
-          <p:cNvSpPr/>
-          <p:nvPr/>
-        </p:nvSpPr>
-        <p:spPr>
-          <a:xfrm>
-            <a:off x="502920" y="1691640"/>
-            <a:ext cx="6400800" cy="914400"/>
-          </a:xfrm>
-          <a:prstGeom prst="rect">
-            <a:avLst/>
-          </a:prstGeom>
-          <a:noFill/>
-          <a:ln/>
-        </p:spPr>
-        <p:txBody>
-          <a:bodyPr wrap="square" rtlCol="0" anchor="ctr"/>
-          <a:lstStyle/>
-          <a:p>
-            <a:pPr indent="0" marL="0">
+              <a:t>21</a:t>
+            </a:r>
+          </a:p>
+          <a:p>
+            <a:pPr marL="0" indent="0" algn="r">
               <a:buNone/>
             </a:pPr>
             <a:r>
-              <a:rPr lang="en-US" sz="5200" b="1" dirty="0">
-                <a:solidFill>
-                  <a:srgbClr val="BF5200"/>
+              <a:rPr lang="en-US" sz="8000" b="1" dirty="0">
+                <a:solidFill>
+                  <a:srgbClr val="BD5100"/>
                 </a:solidFill>
                 <a:latin typeface="Cambria" pitchFamily="34" charset="0"/>
                 <a:ea typeface="Cambria" pitchFamily="34" charset="-122"/>
                 <a:cs typeface="Cambria" pitchFamily="34" charset="-120"/>
               </a:rPr>
-              <a:t>of Music</a:t>
-            </a:r>
-            <a:endParaRPr lang="en-US" sz="5200" dirty="0"/>
+              <a:t>20</a:t>
+            </a:r>
+            <a:r>
+              <a:rPr lang="en-US" sz="8000" b="1" dirty="0">
+                <a:solidFill>
+                  <a:srgbClr val="3C3C3A"/>
+                </a:solidFill>
+                <a:latin typeface="Cambria" pitchFamily="34" charset="0"/>
+                <a:ea typeface="Cambria" pitchFamily="34" charset="-122"/>
+                <a:cs typeface="Cambria" pitchFamily="34" charset="-120"/>
+              </a:rPr>
+              <a:t>20</a:t>
+            </a:r>
+            <a:endParaRPr lang="en-US" sz="8000" dirty="0"/>
+          </a:p>
+        </p:txBody>
+      </p:sp>
+      <p:sp>
+        <p:nvSpPr>
+          <p:cNvPr id="3" name="Text 1"/>
+          <p:cNvSpPr/>
+          <p:nvPr/>
+        </p:nvSpPr>
+        <p:spPr>
+          <a:xfrm>
+            <a:off x="388471" y="1026154"/>
+            <a:ext cx="6515249" cy="2103120"/>
+          </a:xfrm>
+          <a:prstGeom prst="rect">
+            <a:avLst/>
+          </a:prstGeom>
+          <a:noFill/>
+          <a:ln/>
+        </p:spPr>
+        <p:txBody>
+          <a:bodyPr wrap="square" rtlCol="0" anchor="ctr"/>
+          <a:lstStyle/>
+          <a:p>
+            <a:r>
+              <a:rPr lang="it-IT" sz="4800" b="1" dirty="0">
+                <a:solidFill>
+                  <a:srgbClr val="FAFAF8"/>
+                </a:solidFill>
+                <a:latin typeface="Aptos Display" panose="020B0004020202020204" pitchFamily="34" charset="0"/>
+                <a:ea typeface="Apple Color Emoji" pitchFamily="2" charset="0"/>
+              </a:rPr>
+              <a:t>La Trasformazione </a:t>
+            </a:r>
+          </a:p>
+          <a:p>
+            <a:r>
+              <a:rPr lang="it-IT" sz="4800" b="1" dirty="0">
+                <a:solidFill>
+                  <a:srgbClr val="FAFAF8"/>
+                </a:solidFill>
+                <a:latin typeface="Aptos Display" panose="020B0004020202020204" pitchFamily="34" charset="0"/>
+                <a:ea typeface="Apple Color Emoji" pitchFamily="2" charset="0"/>
+              </a:rPr>
+              <a:t>del </a:t>
+            </a:r>
+            <a:r>
+              <a:rPr lang="it-IT" sz="4800" b="1" dirty="0">
+                <a:solidFill>
+                  <a:srgbClr val="C05200"/>
+                </a:solidFill>
+                <a:latin typeface="Aptos Display" panose="020B0004020202020204" pitchFamily="34" charset="0"/>
+                <a:ea typeface="Apple Color Emoji" pitchFamily="2" charset="0"/>
+              </a:rPr>
+              <a:t>Suono</a:t>
+            </a:r>
+          </a:p>
+          <a:p>
+            <a:r>
+              <a:rPr lang="it-IT" sz="4800" b="1" dirty="0">
+                <a:solidFill>
+                  <a:srgbClr val="FAFAF8"/>
+                </a:solidFill>
+                <a:latin typeface="Aptos Display" panose="020B0004020202020204" pitchFamily="34" charset="0"/>
+                <a:ea typeface="Apple Color Emoji" pitchFamily="2" charset="0"/>
+              </a:rPr>
+              <a:t>in un </a:t>
+            </a:r>
+            <a:r>
+              <a:rPr lang="it-IT" sz="4800" b="1" dirty="0">
+                <a:solidFill>
+                  <a:srgbClr val="C05200"/>
+                </a:solidFill>
+                <a:latin typeface="Aptos Display" panose="020B0004020202020204" pitchFamily="34" charset="0"/>
+                <a:ea typeface="Apple Color Emoji" pitchFamily="2" charset="0"/>
+              </a:rPr>
+              <a:t>Secolo</a:t>
+            </a:r>
+          </a:p>
+          <a:p>
+            <a:pPr marL="0" indent="0">
+              <a:buNone/>
+            </a:pPr>
+            <a:endParaRPr lang="en-US" sz="4800" dirty="0"/>
+          </a:p>
+        </p:txBody>
+      </p:sp>
+      <p:sp>
+        <p:nvSpPr>
+          <p:cNvPr id="4" name="Text 2"/>
+          <p:cNvSpPr/>
+          <p:nvPr/>
+        </p:nvSpPr>
+        <p:spPr>
+          <a:xfrm>
+            <a:off x="502920" y="1691640"/>
+            <a:ext cx="6400800" cy="914400"/>
+          </a:xfrm>
+          <a:prstGeom prst="rect">
+            <a:avLst/>
+          </a:prstGeom>
+          <a:noFill/>
+          <a:ln/>
+        </p:spPr>
+        <p:txBody>
+          <a:bodyPr wrap="square" rtlCol="0" anchor="ctr"/>
+          <a:lstStyle/>
+          <a:p>
+            <a:pPr marL="0" indent="0">
+              <a:buNone/>
+            </a:pPr>
+            <a:endParaRPr lang="en-US" sz="4800" dirty="0"/>
           </a:p>
         </p:txBody>
       </p:sp>
@@ -2513,7 +2351,7 @@
         </p:nvSpPr>
         <p:spPr>
           <a:xfrm>
-            <a:off x="502920" y="2743200"/>
+            <a:off x="502920" y="3018114"/>
             <a:ext cx="2286000" cy="36576"/>
           </a:xfrm>
           <a:prstGeom prst="rect">
@@ -2529,6 +2367,13 @@
             <a:prstDash val="solid"/>
           </a:ln>
         </p:spPr>
+        <p:txBody>
+          <a:bodyPr/>
+          <a:lstStyle/>
+          <a:p>
+            <a:endParaRPr lang="it-IT"/>
+          </a:p>
+        </p:txBody>
       </p:sp>
       <p:sp>
         <p:nvSpPr>
@@ -2538,7 +2383,7 @@
         </p:nvSpPr>
         <p:spPr>
           <a:xfrm>
-            <a:off x="502920" y="2926080"/>
+            <a:off x="419256" y="3266741"/>
             <a:ext cx="8138160" cy="411480"/>
           </a:xfrm>
           <a:prstGeom prst="rect">
@@ -2551,58 +2396,53 @@
           <a:bodyPr wrap="square" rtlCol="0" anchor="ctr"/>
           <a:lstStyle/>
           <a:p>
-            <a:pPr indent="0" marL="0">
+            <a:r>
+              <a:rPr lang="it-IT" sz="1400" dirty="0">
+                <a:solidFill>
+                  <a:srgbClr val="D3D1C7"/>
+                </a:solidFill>
+                <a:latin typeface="Calibri" pitchFamily="34" charset="0"/>
+                <a:cs typeface="Calibri" pitchFamily="34" charset="-120"/>
+              </a:rPr>
+              <a:t>Viaggio analitico nelle feature audio del Dataset Spotify</a:t>
+            </a:r>
+          </a:p>
+        </p:txBody>
+      </p:sp>
+      <p:sp>
+        <p:nvSpPr>
+          <p:cNvPr id="7" name="Text 5"/>
+          <p:cNvSpPr/>
+          <p:nvPr/>
+        </p:nvSpPr>
+        <p:spPr>
+          <a:xfrm>
+            <a:off x="413280" y="4612038"/>
+            <a:ext cx="8138160" cy="320040"/>
+          </a:xfrm>
+          <a:prstGeom prst="rect">
+            <a:avLst/>
+          </a:prstGeom>
+          <a:noFill/>
+          <a:ln/>
+        </p:spPr>
+        <p:txBody>
+          <a:bodyPr wrap="square" rtlCol="0" anchor="ctr"/>
+          <a:lstStyle/>
+          <a:p>
+            <a:pPr marL="0" indent="0">
               <a:buNone/>
             </a:pPr>
             <a:r>
-              <a:rPr lang="en-US" sz="1400" dirty="0">
-                <a:solidFill>
-                  <a:srgbClr val="D3D1C7"/>
+              <a:rPr lang="en-US" sz="1000" dirty="0">
+                <a:solidFill>
+                  <a:srgbClr val="B4B2A9"/>
                 </a:solidFill>
                 <a:latin typeface="Calibri" pitchFamily="34" charset="0"/>
                 <a:ea typeface="Calibri" pitchFamily="34" charset="-122"/>
                 <a:cs typeface="Calibri" pitchFamily="34" charset="-120"/>
               </a:rPr>
-              <a:t>Visualizzazione delle Feature Audio · Dataset Spotify 1921–2020</a:t>
-            </a:r>
-            <a:endParaRPr lang="en-US" sz="1400" dirty="0"/>
-          </a:p>
-        </p:txBody>
-      </p:sp>
-      <p:sp>
-        <p:nvSpPr>
-          <p:cNvPr id="7" name="Text 5"/>
-          <p:cNvSpPr/>
-          <p:nvPr/>
-        </p:nvSpPr>
-        <p:spPr>
-          <a:xfrm>
-            <a:off x="502920" y="4480560"/>
-            <a:ext cx="8138160" cy="320040"/>
-          </a:xfrm>
-          <a:prstGeom prst="rect">
-            <a:avLst/>
-          </a:prstGeom>
-          <a:noFill/>
-          <a:ln/>
-        </p:spPr>
-        <p:txBody>
-          <a:bodyPr wrap="square" rtlCol="0" anchor="ctr"/>
-          <a:lstStyle/>
-          <a:p>
-            <a:pPr indent="0" marL="0">
-              <a:buNone/>
-            </a:pPr>
-            <a:r>
-              <a:rPr lang="en-US" sz="1000" dirty="0">
-                <a:solidFill>
-                  <a:srgbClr val="B4B2A9"/>
-                </a:solidFill>
-                <a:latin typeface="Calibri" pitchFamily="34" charset="0"/>
-                <a:ea typeface="Calibri" pitchFamily="34" charset="-122"/>
-                <a:cs typeface="Calibri" pitchFamily="34" charset="-120"/>
-              </a:rPr>
-              <a:t>Corso di Visualizzazione Scientifica  ·  A.A. 2025/26</a:t>
+              <a:t>Arcadia Cipolla M.66969A – Daniele Intra M.53665A   -  A.A. 2025/26</a:t>
             </a:r>
             <a:endParaRPr lang="en-US" sz="1000" dirty="0"/>
           </a:p>
@@ -2624,6 +2464,7 @@
         <a:solidFill>
           <a:srgbClr val="2C2C2A"/>
         </a:solidFill>
+        <a:effectLst/>
       </p:bgPr>
     </p:bg>
     <p:spTree>
@@ -2666,6 +2507,13 @@
             <a:prstDash val="solid"/>
           </a:ln>
         </p:spPr>
+        <p:txBody>
+          <a:bodyPr/>
+          <a:lstStyle/>
+          <a:p>
+            <a:endParaRPr lang="it-IT"/>
+          </a:p>
+        </p:txBody>
       </p:sp>
       <p:sp>
         <p:nvSpPr>
@@ -2688,7 +2536,7 @@
           <a:bodyPr wrap="square" lIns="0" tIns="0" rIns="0" bIns="0" rtlCol="0" anchor="ctr"/>
           <a:lstStyle/>
           <a:p>
-            <a:pPr algn="ctr" indent="0" marL="0">
+            <a:pPr marL="0" indent="0" algn="ctr">
               <a:buNone/>
             </a:pPr>
             <a:r>
@@ -2727,7 +2575,7 @@
           <a:bodyPr wrap="square" rtlCol="0" anchor="ctr"/>
           <a:lstStyle/>
           <a:p>
-            <a:pPr indent="0" marL="0">
+            <a:pPr marL="0" indent="0">
               <a:buNone/>
             </a:pPr>
             <a:r>
@@ -2766,7 +2614,7 @@
           <a:bodyPr wrap="square" rtlCol="0" anchor="ctr"/>
           <a:lstStyle/>
           <a:p>
-            <a:pPr indent="0" marL="0">
+            <a:pPr marL="0" indent="0">
               <a:buNone/>
             </a:pPr>
             <a:r>
@@ -2800,6 +2648,7 @@
         <a:solidFill>
           <a:srgbClr val="FAFAF8"/>
         </a:solidFill>
+        <a:effectLst/>
       </p:bgPr>
     </p:bg>
     <p:spTree>
@@ -2842,6 +2691,13 @@
             <a:prstDash val="solid"/>
           </a:ln>
         </p:spPr>
+        <p:txBody>
+          <a:bodyPr/>
+          <a:lstStyle/>
+          <a:p>
+            <a:endParaRPr lang="it-IT"/>
+          </a:p>
+        </p:txBody>
       </p:sp>
       <p:sp>
         <p:nvSpPr>
@@ -2864,7 +2720,7 @@
           <a:bodyPr wrap="square" lIns="0" tIns="0" rIns="0" bIns="0" rtlCol="0" anchor="ctr"/>
           <a:lstStyle/>
           <a:p>
-            <a:pPr algn="ctr" indent="0" marL="0">
+            <a:pPr marL="0" indent="0" algn="ctr">
               <a:buNone/>
             </a:pPr>
             <a:r>
@@ -2903,7 +2759,7 @@
           <a:bodyPr wrap="square" rtlCol="0" anchor="ctr"/>
           <a:lstStyle/>
           <a:p>
-            <a:pPr indent="0" marL="0">
+            <a:pPr marL="0" indent="0">
               <a:buNone/>
             </a:pPr>
             <a:r>
@@ -2947,13 +2803,20 @@
             <a:prstDash val="solid"/>
           </a:ln>
           <a:effectLst>
-            <a:outerShdw sx="100000" sy="100000" kx="0" ky="0" algn="bl" rotWithShape="0" blurRad="63500" dist="25400" dir="2700000">
+            <a:outerShdw blurRad="63500" dist="25400" dir="2700000" algn="bl" rotWithShape="0">
               <a:srgbClr val="000000">
                 <a:alpha val="8000"/>
               </a:srgbClr>
             </a:outerShdw>
           </a:effectLst>
         </p:spPr>
+        <p:txBody>
+          <a:bodyPr/>
+          <a:lstStyle/>
+          <a:p>
+            <a:endParaRPr lang="it-IT"/>
+          </a:p>
+        </p:txBody>
       </p:sp>
       <p:sp>
         <p:nvSpPr>
@@ -2976,7 +2839,7 @@
           <a:bodyPr wrap="square" rtlCol="0" anchor="ctr"/>
           <a:lstStyle/>
           <a:p>
-            <a:pPr algn="ctr" indent="0" marL="0">
+            <a:pPr marL="0" indent="0" algn="ctr">
               <a:buNone/>
             </a:pPr>
             <a:r>
@@ -2993,7 +2856,7 @@
             <a:endParaRPr lang="en-US" sz="1000" dirty="0"/>
           </a:p>
           <a:p>
-            <a:pPr algn="ctr" indent="0" marL="0">
+            <a:pPr marL="0" indent="0" algn="ctr">
               <a:buNone/>
             </a:pPr>
             <a:r>
@@ -3032,7 +2895,7 @@
           <a:bodyPr wrap="square" rtlCol="0" anchor="ctr"/>
           <a:lstStyle/>
           <a:p>
-            <a:pPr algn="l" indent="0" marL="0">
+            <a:pPr marL="0" indent="0" algn="l">
               <a:buNone/>
             </a:pPr>
             <a:r>
@@ -3066,6 +2929,7 @@
         <a:solidFill>
           <a:srgbClr val="FAFAF8"/>
         </a:solidFill>
+        <a:effectLst/>
       </p:bgPr>
     </p:bg>
     <p:spTree>
@@ -3108,6 +2972,13 @@
             <a:prstDash val="solid"/>
           </a:ln>
         </p:spPr>
+        <p:txBody>
+          <a:bodyPr/>
+          <a:lstStyle/>
+          <a:p>
+            <a:endParaRPr lang="it-IT"/>
+          </a:p>
+        </p:txBody>
       </p:sp>
       <p:sp>
         <p:nvSpPr>
@@ -3130,7 +3001,7 @@
           <a:bodyPr wrap="square" lIns="0" tIns="0" rIns="0" bIns="0" rtlCol="0" anchor="ctr"/>
           <a:lstStyle/>
           <a:p>
-            <a:pPr algn="ctr" indent="0" marL="0">
+            <a:pPr marL="0" indent="0" algn="ctr">
               <a:buNone/>
             </a:pPr>
             <a:r>
@@ -3169,7 +3040,7 @@
           <a:bodyPr wrap="square" rtlCol="0" anchor="ctr"/>
           <a:lstStyle/>
           <a:p>
-            <a:pPr indent="0" marL="0">
+            <a:pPr marL="0" indent="0">
               <a:buNone/>
             </a:pPr>
             <a:r>
@@ -3213,13 +3084,20 @@
             <a:prstDash val="solid"/>
           </a:ln>
           <a:effectLst>
-            <a:outerShdw sx="100000" sy="100000" kx="0" ky="0" algn="bl" rotWithShape="0" blurRad="63500" dist="25400" dir="2700000">
+            <a:outerShdw blurRad="63500" dist="25400" dir="2700000" algn="bl" rotWithShape="0">
               <a:srgbClr val="000000">
                 <a:alpha val="8000"/>
               </a:srgbClr>
             </a:outerShdw>
           </a:effectLst>
         </p:spPr>
+        <p:txBody>
+          <a:bodyPr/>
+          <a:lstStyle/>
+          <a:p>
+            <a:endParaRPr lang="it-IT"/>
+          </a:p>
+        </p:txBody>
       </p:sp>
       <p:sp>
         <p:nvSpPr>
@@ -3242,7 +3120,7 @@
           <a:bodyPr wrap="square" rtlCol="0" anchor="ctr"/>
           <a:lstStyle/>
           <a:p>
-            <a:pPr algn="ctr" indent="0" marL="0">
+            <a:pPr marL="0" indent="0" algn="ctr">
               <a:buNone/>
             </a:pPr>
             <a:r>
@@ -3259,7 +3137,7 @@
             <a:endParaRPr lang="en-US" sz="1000" dirty="0"/>
           </a:p>
           <a:p>
-            <a:pPr algn="ctr" indent="0" marL="0">
+            <a:pPr marL="0" indent="0" algn="ctr">
               <a:buNone/>
             </a:pPr>
             <a:r>
@@ -3298,7 +3176,7 @@
           <a:bodyPr wrap="square" rtlCol="0" anchor="ctr"/>
           <a:lstStyle/>
           <a:p>
-            <a:pPr algn="l" indent="0" marL="0">
+            <a:pPr marL="0" indent="0" algn="l">
               <a:buNone/>
             </a:pPr>
             <a:r>
@@ -3332,6 +3210,7 @@
         <a:solidFill>
           <a:srgbClr val="2C2C2A"/>
         </a:solidFill>
+        <a:effectLst/>
       </p:bgPr>
     </p:bg>
     <p:spTree>
@@ -3374,6 +3253,13 @@
             <a:prstDash val="solid"/>
           </a:ln>
         </p:spPr>
+        <p:txBody>
+          <a:bodyPr/>
+          <a:lstStyle/>
+          <a:p>
+            <a:endParaRPr lang="it-IT"/>
+          </a:p>
+        </p:txBody>
       </p:sp>
       <p:sp>
         <p:nvSpPr>
@@ -3396,7 +3282,7 @@
           <a:bodyPr wrap="square" lIns="0" tIns="0" rIns="0" bIns="0" rtlCol="0" anchor="ctr"/>
           <a:lstStyle/>
           <a:p>
-            <a:pPr algn="ctr" indent="0" marL="0">
+            <a:pPr marL="0" indent="0" algn="ctr">
               <a:buNone/>
             </a:pPr>
             <a:r>
@@ -3435,7 +3321,7 @@
           <a:bodyPr wrap="square" rtlCol="0" anchor="ctr"/>
           <a:lstStyle/>
           <a:p>
-            <a:pPr indent="0" marL="0">
+            <a:pPr marL="0" indent="0">
               <a:buNone/>
             </a:pPr>
             <a:r>
@@ -3474,7 +3360,7 @@
           <a:bodyPr wrap="square" rtlCol="0" anchor="ctr"/>
           <a:lstStyle/>
           <a:p>
-            <a:pPr indent="0" marL="0">
+            <a:pPr marL="0" indent="0">
               <a:buNone/>
             </a:pPr>
             <a:r>
@@ -3508,6 +3394,7 @@
         <a:solidFill>
           <a:srgbClr val="FAFAF8"/>
         </a:solidFill>
+        <a:effectLst/>
       </p:bgPr>
     </p:bg>
     <p:spTree>
@@ -3550,6 +3437,13 @@
             <a:prstDash val="solid"/>
           </a:ln>
         </p:spPr>
+        <p:txBody>
+          <a:bodyPr/>
+          <a:lstStyle/>
+          <a:p>
+            <a:endParaRPr lang="it-IT"/>
+          </a:p>
+        </p:txBody>
       </p:sp>
       <p:sp>
         <p:nvSpPr>
@@ -3572,7 +3466,7 @@
           <a:bodyPr wrap="square" lIns="0" tIns="0" rIns="0" bIns="0" rtlCol="0" anchor="ctr"/>
           <a:lstStyle/>
           <a:p>
-            <a:pPr algn="ctr" indent="0" marL="0">
+            <a:pPr marL="0" indent="0" algn="ctr">
               <a:buNone/>
             </a:pPr>
             <a:r>
@@ -3611,7 +3505,7 @@
           <a:bodyPr wrap="square" rtlCol="0" anchor="ctr"/>
           <a:lstStyle/>
           <a:p>
-            <a:pPr indent="0" marL="0">
+            <a:pPr marL="0" indent="0">
               <a:buNone/>
             </a:pPr>
             <a:r>
@@ -3655,13 +3549,20 @@
             <a:prstDash val="solid"/>
           </a:ln>
           <a:effectLst>
-            <a:outerShdw sx="100000" sy="100000" kx="0" ky="0" algn="bl" rotWithShape="0" blurRad="63500" dist="25400" dir="2700000">
+            <a:outerShdw blurRad="63500" dist="25400" dir="2700000" algn="bl" rotWithShape="0">
               <a:srgbClr val="000000">
                 <a:alpha val="8000"/>
               </a:srgbClr>
             </a:outerShdw>
           </a:effectLst>
         </p:spPr>
+        <p:txBody>
+          <a:bodyPr/>
+          <a:lstStyle/>
+          <a:p>
+            <a:endParaRPr lang="it-IT"/>
+          </a:p>
+        </p:txBody>
       </p:sp>
       <p:sp>
         <p:nvSpPr>
@@ -3684,7 +3585,7 @@
           <a:bodyPr wrap="square" rtlCol="0" anchor="ctr"/>
           <a:lstStyle/>
           <a:p>
-            <a:pPr algn="ctr" indent="0" marL="0">
+            <a:pPr marL="0" indent="0" algn="ctr">
               <a:buNone/>
             </a:pPr>
             <a:r>
@@ -3701,7 +3602,7 @@
             <a:endParaRPr lang="en-US" sz="1000" dirty="0"/>
           </a:p>
           <a:p>
-            <a:pPr algn="ctr" indent="0" marL="0">
+            <a:pPr marL="0" indent="0" algn="ctr">
               <a:buNone/>
             </a:pPr>
             <a:r>
@@ -3740,7 +3641,7 @@
           <a:bodyPr wrap="square" rtlCol="0" anchor="ctr"/>
           <a:lstStyle/>
           <a:p>
-            <a:pPr algn="l" indent="0" marL="0">
+            <a:pPr marL="0" indent="0" algn="l">
               <a:buNone/>
             </a:pPr>
             <a:r>
@@ -3774,6 +3675,7 @@
         <a:solidFill>
           <a:srgbClr val="FAFAF8"/>
         </a:solidFill>
+        <a:effectLst/>
       </p:bgPr>
     </p:bg>
     <p:spTree>
@@ -3816,6 +3718,13 @@
             <a:prstDash val="solid"/>
           </a:ln>
         </p:spPr>
+        <p:txBody>
+          <a:bodyPr/>
+          <a:lstStyle/>
+          <a:p>
+            <a:endParaRPr lang="it-IT"/>
+          </a:p>
+        </p:txBody>
       </p:sp>
       <p:sp>
         <p:nvSpPr>
@@ -3838,7 +3747,7 @@
           <a:bodyPr wrap="square" lIns="0" tIns="0" rIns="0" bIns="0" rtlCol="0" anchor="ctr"/>
           <a:lstStyle/>
           <a:p>
-            <a:pPr algn="ctr" indent="0" marL="0">
+            <a:pPr marL="0" indent="0" algn="ctr">
               <a:buNone/>
             </a:pPr>
             <a:r>
@@ -3877,7 +3786,7 @@
           <a:bodyPr wrap="square" rtlCol="0" anchor="ctr"/>
           <a:lstStyle/>
           <a:p>
-            <a:pPr indent="0" marL="0">
+            <a:pPr marL="0" indent="0">
               <a:buNone/>
             </a:pPr>
             <a:r>
@@ -3918,9 +3827,27 @@
             <a:tbl>
               <a:tblPr/>
               <a:tblGrid>
-                <a:gridCol w="1554480"/>
-                <a:gridCol w="960120"/>
-                <a:gridCol w="960120"/>
+                <a:gridCol w="1554480">
+                  <a:extLst>
+                    <a:ext uri="{9D8B030D-6E8A-4147-A177-3AD203B41FA5}">
+                      <a16:colId xmlns:a16="http://schemas.microsoft.com/office/drawing/2014/main" val="20000"/>
+                    </a:ext>
+                  </a:extLst>
+                </a:gridCol>
+                <a:gridCol w="960120">
+                  <a:extLst>
+                    <a:ext uri="{9D8B030D-6E8A-4147-A177-3AD203B41FA5}">
+                      <a16:colId xmlns:a16="http://schemas.microsoft.com/office/drawing/2014/main" val="20001"/>
+                    </a:ext>
+                  </a:extLst>
+                </a:gridCol>
+                <a:gridCol w="960120">
+                  <a:extLst>
+                    <a:ext uri="{9D8B030D-6E8A-4147-A177-3AD203B41FA5}">
+                      <a16:colId xmlns:a16="http://schemas.microsoft.com/office/drawing/2014/main" val="20002"/>
+                    </a:ext>
+                  </a:extLst>
+                </a:gridCol>
               </a:tblGrid>
               <a:tr h="320040">
                 <a:tc>
@@ -3928,7 +3855,7 @@
                     <a:bodyPr/>
                     <a:lstStyle/>
                     <a:p>
-                      <a:pPr indent="0" marL="0">
+                      <a:pPr marL="0" indent="0">
                         <a:buNone/>
                       </a:pPr>
                       <a:r>
@@ -3949,7 +3876,7 @@
                       </a:endParaRPr>
                     </a:p>
                   </a:txBody>
-                  <a:tcPr marL="91440" marR="91440" marT="45720" marB="45720">
+                  <a:tcPr>
                     <a:lnL w="6350" cap="flat" cmpd="sng" algn="ctr">
                       <a:solidFill>
                         <a:srgbClr val="D3D1C7"/>
@@ -3996,7 +3923,7 @@
                     <a:bodyPr/>
                     <a:lstStyle/>
                     <a:p>
-                      <a:pPr indent="0" marL="0">
+                      <a:pPr marL="0" indent="0">
                         <a:buNone/>
                       </a:pPr>
                       <a:r>
@@ -4017,7 +3944,7 @@
                       </a:endParaRPr>
                     </a:p>
                   </a:txBody>
-                  <a:tcPr marL="91440" marR="91440" marT="45720" marB="45720">
+                  <a:tcPr>
                     <a:lnL w="6350" cap="flat" cmpd="sng" algn="ctr">
                       <a:solidFill>
                         <a:srgbClr val="D3D1C7"/>
@@ -4064,7 +3991,7 @@
                     <a:bodyPr/>
                     <a:lstStyle/>
                     <a:p>
-                      <a:pPr indent="0" marL="0">
+                      <a:pPr marL="0" indent="0">
                         <a:buNone/>
                       </a:pPr>
                       <a:r>
@@ -4085,7 +4012,7 @@
                       </a:endParaRPr>
                     </a:p>
                   </a:txBody>
-                  <a:tcPr marL="91440" marR="91440" marT="45720" marB="45720">
+                  <a:tcPr>
                     <a:lnL w="6350" cap="flat" cmpd="sng" algn="ctr">
                       <a:solidFill>
                         <a:srgbClr val="D3D1C7"/>
@@ -4127,6 +4054,11 @@
                     </a:solidFill>
                   </a:tcPr>
                 </a:tc>
+                <a:extLst>
+                  <a:ext uri="{0D108BD9-81ED-4DB2-BD59-A6C34878D82A}">
+                    <a16:rowId xmlns:a16="http://schemas.microsoft.com/office/drawing/2014/main" val="10000"/>
+                  </a:ext>
+                </a:extLst>
               </a:tr>
               <a:tr h="320040">
                 <a:tc>
@@ -4134,7 +4066,7 @@
                     <a:bodyPr/>
                     <a:lstStyle/>
                     <a:p>
-                      <a:pPr indent="0" marL="0">
+                      <a:pPr marL="0" indent="0">
                         <a:buNone/>
                       </a:pPr>
                       <a:r>
@@ -4155,7 +4087,7 @@
                       </a:endParaRPr>
                     </a:p>
                   </a:txBody>
-                  <a:tcPr marL="91440" marR="91440" marT="45720" marB="45720">
+                  <a:tcPr>
                     <a:lnL w="6350" cap="flat" cmpd="sng" algn="ctr">
                       <a:solidFill>
                         <a:srgbClr val="D3D1C7"/>
@@ -4199,7 +4131,7 @@
                     <a:bodyPr/>
                     <a:lstStyle/>
                     <a:p>
-                      <a:pPr indent="0" marL="0">
+                      <a:pPr marL="0" indent="0">
                         <a:buNone/>
                       </a:pPr>
                       <a:r>
@@ -4220,7 +4152,7 @@
                       </a:endParaRPr>
                     </a:p>
                   </a:txBody>
-                  <a:tcPr marL="91440" marR="91440" marT="45720" marB="45720">
+                  <a:tcPr>
                     <a:lnL w="6350" cap="flat" cmpd="sng" algn="ctr">
                       <a:solidFill>
                         <a:srgbClr val="D3D1C7"/>
@@ -4264,7 +4196,7 @@
                     <a:bodyPr/>
                     <a:lstStyle/>
                     <a:p>
-                      <a:pPr indent="0" marL="0">
+                      <a:pPr marL="0" indent="0">
                         <a:buNone/>
                       </a:pPr>
                       <a:r>
@@ -4285,7 +4217,7 @@
                       </a:endParaRPr>
                     </a:p>
                   </a:txBody>
-                  <a:tcPr marL="91440" marR="91440" marT="45720" marB="45720">
+                  <a:tcPr>
                     <a:lnL w="6350" cap="flat" cmpd="sng" algn="ctr">
                       <a:solidFill>
                         <a:srgbClr val="D3D1C7"/>
@@ -4324,6 +4256,11 @@
                     </a:lnB>
                   </a:tcPr>
                 </a:tc>
+                <a:extLst>
+                  <a:ext uri="{0D108BD9-81ED-4DB2-BD59-A6C34878D82A}">
+                    <a16:rowId xmlns:a16="http://schemas.microsoft.com/office/drawing/2014/main" val="10001"/>
+                  </a:ext>
+                </a:extLst>
               </a:tr>
               <a:tr h="320040">
                 <a:tc>
@@ -4331,7 +4268,7 @@
                     <a:bodyPr/>
                     <a:lstStyle/>
                     <a:p>
-                      <a:pPr indent="0" marL="0">
+                      <a:pPr marL="0" indent="0">
                         <a:buNone/>
                       </a:pPr>
                       <a:r>
@@ -4352,7 +4289,7 @@
                       </a:endParaRPr>
                     </a:p>
                   </a:txBody>
-                  <a:tcPr marL="91440" marR="91440" marT="45720" marB="45720">
+                  <a:tcPr>
                     <a:lnL w="6350" cap="flat" cmpd="sng" algn="ctr">
                       <a:solidFill>
                         <a:srgbClr val="D3D1C7"/>
@@ -4396,7 +4333,7 @@
                     <a:bodyPr/>
                     <a:lstStyle/>
                     <a:p>
-                      <a:pPr indent="0" marL="0">
+                      <a:pPr marL="0" indent="0">
                         <a:buNone/>
                       </a:pPr>
                       <a:r>
@@ -4417,7 +4354,7 @@
                       </a:endParaRPr>
                     </a:p>
                   </a:txBody>
-                  <a:tcPr marL="91440" marR="91440" marT="45720" marB="45720">
+                  <a:tcPr>
                     <a:lnL w="6350" cap="flat" cmpd="sng" algn="ctr">
                       <a:solidFill>
                         <a:srgbClr val="D3D1C7"/>
@@ -4461,7 +4398,7 @@
                     <a:bodyPr/>
                     <a:lstStyle/>
                     <a:p>
-                      <a:pPr indent="0" marL="0">
+                      <a:pPr marL="0" indent="0">
                         <a:buNone/>
                       </a:pPr>
                       <a:r>
@@ -4482,7 +4419,7 @@
                       </a:endParaRPr>
                     </a:p>
                   </a:txBody>
-                  <a:tcPr marL="91440" marR="91440" marT="45720" marB="45720">
+                  <a:tcPr>
                     <a:lnL w="6350" cap="flat" cmpd="sng" algn="ctr">
                       <a:solidFill>
                         <a:srgbClr val="D3D1C7"/>
@@ -4521,6 +4458,11 @@
                     </a:lnB>
                   </a:tcPr>
                 </a:tc>
+                <a:extLst>
+                  <a:ext uri="{0D108BD9-81ED-4DB2-BD59-A6C34878D82A}">
+                    <a16:rowId xmlns:a16="http://schemas.microsoft.com/office/drawing/2014/main" val="10002"/>
+                  </a:ext>
+                </a:extLst>
               </a:tr>
               <a:tr h="320040">
                 <a:tc>
@@ -4528,7 +4470,7 @@
                     <a:bodyPr/>
                     <a:lstStyle/>
                     <a:p>
-                      <a:pPr indent="0" marL="0">
+                      <a:pPr marL="0" indent="0">
                         <a:buNone/>
                       </a:pPr>
                       <a:r>
@@ -4549,7 +4491,7 @@
                       </a:endParaRPr>
                     </a:p>
                   </a:txBody>
-                  <a:tcPr marL="91440" marR="91440" marT="45720" marB="45720">
+                  <a:tcPr>
                     <a:lnL w="6350" cap="flat" cmpd="sng" algn="ctr">
                       <a:solidFill>
                         <a:srgbClr val="D3D1C7"/>
@@ -4593,7 +4535,7 @@
                     <a:bodyPr/>
                     <a:lstStyle/>
                     <a:p>
-                      <a:pPr indent="0" marL="0">
+                      <a:pPr marL="0" indent="0">
                         <a:buNone/>
                       </a:pPr>
                       <a:r>
@@ -4614,7 +4556,7 @@
                       </a:endParaRPr>
                     </a:p>
                   </a:txBody>
-                  <a:tcPr marL="91440" marR="91440" marT="45720" marB="45720">
+                  <a:tcPr>
                     <a:lnL w="6350" cap="flat" cmpd="sng" algn="ctr">
                       <a:solidFill>
                         <a:srgbClr val="D3D1C7"/>
@@ -4658,7 +4600,7 @@
                     <a:bodyPr/>
                     <a:lstStyle/>
                     <a:p>
-                      <a:pPr indent="0" marL="0">
+                      <a:pPr marL="0" indent="0">
                         <a:buNone/>
                       </a:pPr>
                       <a:r>
@@ -4679,7 +4621,7 @@
                       </a:endParaRPr>
                     </a:p>
                   </a:txBody>
-                  <a:tcPr marL="91440" marR="91440" marT="45720" marB="45720">
+                  <a:tcPr>
                     <a:lnL w="6350" cap="flat" cmpd="sng" algn="ctr">
                       <a:solidFill>
                         <a:srgbClr val="D3D1C7"/>
@@ -4718,6 +4660,11 @@
                     </a:lnB>
                   </a:tcPr>
                 </a:tc>
+                <a:extLst>
+                  <a:ext uri="{0D108BD9-81ED-4DB2-BD59-A6C34878D82A}">
+                    <a16:rowId xmlns:a16="http://schemas.microsoft.com/office/drawing/2014/main" val="10003"/>
+                  </a:ext>
+                </a:extLst>
               </a:tr>
             </a:tbl>
           </a:graphicData>
@@ -4749,6 +4696,13 @@
             <a:prstDash val="solid"/>
           </a:ln>
         </p:spPr>
+        <p:txBody>
+          <a:bodyPr/>
+          <a:lstStyle/>
+          <a:p>
+            <a:endParaRPr lang="it-IT"/>
+          </a:p>
+        </p:txBody>
       </p:sp>
       <p:sp>
         <p:nvSpPr>
@@ -4771,7 +4725,7 @@
           <a:bodyPr wrap="square" rtlCol="0" anchor="ctr"/>
           <a:lstStyle/>
           <a:p>
-            <a:pPr indent="0" marL="0">
+            <a:pPr marL="0" indent="0">
               <a:buNone/>
             </a:pPr>
             <a:r>
@@ -4815,13 +4769,20 @@
             <a:prstDash val="solid"/>
           </a:ln>
           <a:effectLst>
-            <a:outerShdw sx="100000" sy="100000" kx="0" ky="0" algn="bl" rotWithShape="0" blurRad="63500" dist="25400" dir="2700000">
+            <a:outerShdw blurRad="63500" dist="25400" dir="2700000" algn="bl" rotWithShape="0">
               <a:srgbClr val="000000">
                 <a:alpha val="8000"/>
               </a:srgbClr>
             </a:outerShdw>
           </a:effectLst>
         </p:spPr>
+        <p:txBody>
+          <a:bodyPr/>
+          <a:lstStyle/>
+          <a:p>
+            <a:endParaRPr lang="it-IT"/>
+          </a:p>
+        </p:txBody>
       </p:sp>
       <p:sp>
         <p:nvSpPr>
@@ -4844,7 +4805,7 @@
           <a:bodyPr wrap="square" rtlCol="0" anchor="ctr"/>
           <a:lstStyle/>
           <a:p>
-            <a:pPr algn="ctr" indent="0" marL="0">
+            <a:pPr marL="0" indent="0" algn="ctr">
               <a:buNone/>
             </a:pPr>
             <a:r>
@@ -4861,7 +4822,7 @@
             <a:endParaRPr lang="en-US" sz="1000" dirty="0"/>
           </a:p>
           <a:p>
-            <a:pPr algn="ctr" indent="0" marL="0">
+            <a:pPr marL="0" indent="0" algn="ctr">
               <a:buNone/>
             </a:pPr>
             <a:r>
@@ -4900,7 +4861,7 @@
           <a:bodyPr wrap="square" rtlCol="0" anchor="ctr"/>
           <a:lstStyle/>
           <a:p>
-            <a:pPr algn="l" indent="0" marL="0">
+            <a:pPr marL="0" indent="0" algn="l">
               <a:buNone/>
             </a:pPr>
             <a:r>
@@ -4934,6 +4895,7 @@
         <a:solidFill>
           <a:srgbClr val="2C2C2A"/>
         </a:solidFill>
+        <a:effectLst/>
       </p:bgPr>
     </p:bg>
     <p:spTree>
@@ -4971,7 +4933,7 @@
           <a:bodyPr wrap="square" rtlCol="0" anchor="ctr"/>
           <a:lstStyle/>
           <a:p>
-            <a:pPr indent="0" marL="0">
+            <a:pPr marL="0" indent="0">
               <a:buNone/>
             </a:pPr>
             <a:r>
@@ -5013,6 +4975,13 @@
             <a:prstDash val="solid"/>
           </a:ln>
         </p:spPr>
+        <p:txBody>
+          <a:bodyPr/>
+          <a:lstStyle/>
+          <a:p>
+            <a:endParaRPr lang="it-IT"/>
+          </a:p>
+        </p:txBody>
       </p:sp>
       <p:sp>
         <p:nvSpPr>
@@ -5035,7 +5004,7 @@
           <a:bodyPr wrap="square" lIns="0" tIns="0" rIns="0" bIns="0" rtlCol="0" anchor="ctr"/>
           <a:lstStyle/>
           <a:p>
-            <a:pPr algn="ctr" indent="0" marL="0">
+            <a:pPr marL="0" indent="0" algn="ctr">
               <a:buNone/>
             </a:pPr>
             <a:r>
@@ -5074,7 +5043,7 @@
           <a:bodyPr wrap="square" rtlCol="0" anchor="ctr"/>
           <a:lstStyle/>
           <a:p>
-            <a:pPr indent="0" marL="0">
+            <a:pPr marL="0" indent="0">
               <a:buNone/>
             </a:pPr>
             <a:r>
@@ -5113,7 +5082,7 @@
           <a:bodyPr wrap="square" rtlCol="0" anchor="ctr"/>
           <a:lstStyle/>
           <a:p>
-            <a:pPr indent="0" marL="0">
+            <a:pPr marL="0" indent="0">
               <a:buNone/>
             </a:pPr>
             <a:r>
@@ -5155,6 +5124,13 @@
             <a:prstDash val="solid"/>
           </a:ln>
         </p:spPr>
+        <p:txBody>
+          <a:bodyPr/>
+          <a:lstStyle/>
+          <a:p>
+            <a:endParaRPr lang="it-IT"/>
+          </a:p>
+        </p:txBody>
       </p:sp>
       <p:sp>
         <p:nvSpPr>
@@ -5177,7 +5153,7 @@
           <a:bodyPr wrap="square" lIns="0" tIns="0" rIns="0" bIns="0" rtlCol="0" anchor="ctr"/>
           <a:lstStyle/>
           <a:p>
-            <a:pPr algn="ctr" indent="0" marL="0">
+            <a:pPr marL="0" indent="0" algn="ctr">
               <a:buNone/>
             </a:pPr>
             <a:r>
@@ -5216,7 +5192,7 @@
           <a:bodyPr wrap="square" rtlCol="0" anchor="ctr"/>
           <a:lstStyle/>
           <a:p>
-            <a:pPr indent="0" marL="0">
+            <a:pPr marL="0" indent="0">
               <a:buNone/>
             </a:pPr>
             <a:r>
@@ -5255,7 +5231,7 @@
           <a:bodyPr wrap="square" rtlCol="0" anchor="ctr"/>
           <a:lstStyle/>
           <a:p>
-            <a:pPr indent="0" marL="0">
+            <a:pPr marL="0" indent="0">
               <a:buNone/>
             </a:pPr>
             <a:r>
@@ -5297,6 +5273,13 @@
             <a:prstDash val="solid"/>
           </a:ln>
         </p:spPr>
+        <p:txBody>
+          <a:bodyPr/>
+          <a:lstStyle/>
+          <a:p>
+            <a:endParaRPr lang="it-IT"/>
+          </a:p>
+        </p:txBody>
       </p:sp>
       <p:sp>
         <p:nvSpPr>
@@ -5319,7 +5302,7 @@
           <a:bodyPr wrap="square" lIns="0" tIns="0" rIns="0" bIns="0" rtlCol="0" anchor="ctr"/>
           <a:lstStyle/>
           <a:p>
-            <a:pPr algn="ctr" indent="0" marL="0">
+            <a:pPr marL="0" indent="0" algn="ctr">
               <a:buNone/>
             </a:pPr>
             <a:r>
@@ -5358,7 +5341,7 @@
           <a:bodyPr wrap="square" rtlCol="0" anchor="ctr"/>
           <a:lstStyle/>
           <a:p>
-            <a:pPr indent="0" marL="0">
+            <a:pPr marL="0" indent="0">
               <a:buNone/>
             </a:pPr>
             <a:r>
@@ -5397,7 +5380,7 @@
           <a:bodyPr wrap="square" rtlCol="0" anchor="ctr"/>
           <a:lstStyle/>
           <a:p>
-            <a:pPr indent="0" marL="0">
+            <a:pPr marL="0" indent="0">
               <a:buNone/>
             </a:pPr>
             <a:r>
@@ -5431,6 +5414,7 @@
         <a:solidFill>
           <a:srgbClr val="FAFAF8"/>
         </a:solidFill>
+        <a:effectLst/>
       </p:bgPr>
     </p:bg>
     <p:spTree>
@@ -5468,7 +5452,7 @@
           <a:bodyPr wrap="square" rtlCol="0" anchor="ctr"/>
           <a:lstStyle/>
           <a:p>
-            <a:pPr indent="0" marL="0">
+            <a:pPr marL="0" indent="0">
               <a:buNone/>
             </a:pPr>
             <a:r>
@@ -5512,13 +5496,20 @@
             <a:prstDash val="solid"/>
           </a:ln>
           <a:effectLst>
-            <a:outerShdw sx="100000" sy="100000" kx="0" ky="0" algn="bl" rotWithShape="0" blurRad="63500" dist="25400" dir="2700000">
+            <a:outerShdw blurRad="63500" dist="25400" dir="2700000" algn="bl" rotWithShape="0">
               <a:srgbClr val="000000">
                 <a:alpha val="8000"/>
               </a:srgbClr>
             </a:outerShdw>
           </a:effectLst>
         </p:spPr>
+        <p:txBody>
+          <a:bodyPr/>
+          <a:lstStyle/>
+          <a:p>
+            <a:endParaRPr lang="it-IT"/>
+          </a:p>
+        </p:txBody>
       </p:sp>
       <p:sp>
         <p:nvSpPr>
@@ -5541,7 +5532,7 @@
           <a:bodyPr wrap="square" rtlCol="0" anchor="ctr"/>
           <a:lstStyle/>
           <a:p>
-            <a:pPr indent="0" marL="0">
+            <a:pPr marL="0" indent="0">
               <a:buNone/>
             </a:pPr>
             <a:r>
@@ -5580,7 +5571,7 @@
           <a:bodyPr wrap="square" rtlCol="0" anchor="ctr"/>
           <a:lstStyle/>
           <a:p>
-            <a:pPr indent="0" marL="0">
+            <a:pPr marL="0" indent="0">
               <a:buNone/>
             </a:pPr>
             <a:r>
@@ -5615,22 +5606,34 @@
             </a:avLst>
           </a:prstGeom>
           <a:solidFill>
-            <a:srgbClr val="FCF0F0"/>
+            <a:schemeClr val="accent6">
+              <a:lumMod val="20000"/>
+              <a:lumOff val="80000"/>
+            </a:schemeClr>
           </a:solidFill>
-          <a:ln w="6350">
-            <a:solidFill>
-              <a:srgbClr val="A32D2D"/>
-            </a:solidFill>
-            <a:prstDash val="solid"/>
-          </a:ln>
-          <a:effectLst>
-            <a:outerShdw sx="100000" sy="100000" kx="0" ky="0" algn="bl" rotWithShape="0" blurRad="63500" dist="25400" dir="2700000">
-              <a:srgbClr val="000000">
-                <a:alpha val="8000"/>
-              </a:srgbClr>
-            </a:outerShdw>
-          </a:effectLst>
-        </p:spPr>
+          <a:ln/>
+        </p:spPr>
+        <p:style>
+          <a:lnRef idx="2">
+            <a:schemeClr val="accent6"/>
+          </a:lnRef>
+          <a:fillRef idx="1">
+            <a:schemeClr val="lt1"/>
+          </a:fillRef>
+          <a:effectRef idx="0">
+            <a:schemeClr val="accent6"/>
+          </a:effectRef>
+          <a:fontRef idx="minor">
+            <a:schemeClr val="dk1"/>
+          </a:fontRef>
+        </p:style>
+        <p:txBody>
+          <a:bodyPr/>
+          <a:lstStyle/>
+          <a:p>
+            <a:endParaRPr lang="it-IT"/>
+          </a:p>
+        </p:txBody>
       </p:sp>
       <p:sp>
         <p:nvSpPr>
@@ -5653,13 +5656,15 @@
           <a:bodyPr wrap="square" rtlCol="0" anchor="ctr"/>
           <a:lstStyle/>
           <a:p>
-            <a:pPr indent="0" marL="0">
+            <a:pPr marL="0" indent="0">
               <a:buNone/>
             </a:pPr>
             <a:r>
               <a:rPr lang="en-US" sz="1200" b="1" dirty="0">
                 <a:solidFill>
-                  <a:srgbClr val="A32D2D"/>
+                  <a:schemeClr val="accent6">
+                    <a:lumMod val="75000"/>
+                  </a:schemeClr>
                 </a:solidFill>
                 <a:latin typeface="Cambria" pitchFamily="34" charset="0"/>
                 <a:ea typeface="Cambria" pitchFamily="34" charset="-122"/>
@@ -5667,7 +5672,13 @@
               </a:rPr>
               <a:t>Varianza nascosta (rigore scientifico)</a:t>
             </a:r>
-            <a:endParaRPr lang="en-US" sz="1200" dirty="0"/>
+            <a:endParaRPr lang="en-US" sz="1200" dirty="0">
+              <a:solidFill>
+                <a:schemeClr val="accent6">
+                  <a:lumMod val="75000"/>
+                </a:schemeClr>
+              </a:solidFill>
+            </a:endParaRPr>
           </a:p>
         </p:txBody>
       </p:sp>
@@ -5692,7 +5703,7 @@
           <a:bodyPr wrap="square" rtlCol="0" anchor="ctr"/>
           <a:lstStyle/>
           <a:p>
-            <a:pPr indent="0" marL="0">
+            <a:pPr marL="0" indent="0">
               <a:buNone/>
             </a:pPr>
             <a:r>
@@ -5704,7 +5715,139 @@
                 <a:ea typeface="Calibri" pitchFamily="34" charset="-122"/>
                 <a:cs typeface="Calibri" pitchFamily="34" charset="-120"/>
               </a:rPr>
-              <a:t>La media mobile non mostra la dispersione reale. → fill_between per intervallo di confidenza al 95%.</a:t>
+              <a:t>La media mobile non </a:t>
+            </a:r>
+            <a:r>
+              <a:rPr lang="en-US" sz="1100" dirty="0" err="1">
+                <a:solidFill>
+                  <a:srgbClr val="444441"/>
+                </a:solidFill>
+                <a:latin typeface="Calibri" pitchFamily="34" charset="0"/>
+                <a:ea typeface="Calibri" pitchFamily="34" charset="-122"/>
+                <a:cs typeface="Calibri" pitchFamily="34" charset="-120"/>
+              </a:rPr>
+              <a:t>mostrava</a:t>
+            </a:r>
+            <a:r>
+              <a:rPr lang="en-US" sz="1100" dirty="0">
+                <a:solidFill>
+                  <a:srgbClr val="444441"/>
+                </a:solidFill>
+                <a:latin typeface="Calibri" pitchFamily="34" charset="0"/>
+                <a:ea typeface="Calibri" pitchFamily="34" charset="-122"/>
+                <a:cs typeface="Calibri" pitchFamily="34" charset="-120"/>
+              </a:rPr>
+              <a:t> la </a:t>
+            </a:r>
+            <a:r>
+              <a:rPr lang="en-US" sz="1100" dirty="0" err="1">
+                <a:solidFill>
+                  <a:srgbClr val="444441"/>
+                </a:solidFill>
+                <a:latin typeface="Calibri" pitchFamily="34" charset="0"/>
+                <a:ea typeface="Calibri" pitchFamily="34" charset="-122"/>
+                <a:cs typeface="Calibri" pitchFamily="34" charset="-120"/>
+              </a:rPr>
+              <a:t>dispersione</a:t>
+            </a:r>
+            <a:r>
+              <a:rPr lang="en-US" sz="1100" dirty="0">
+                <a:solidFill>
+                  <a:srgbClr val="444441"/>
+                </a:solidFill>
+                <a:latin typeface="Calibri" pitchFamily="34" charset="0"/>
+                <a:ea typeface="Calibri" pitchFamily="34" charset="-122"/>
+                <a:cs typeface="Calibri" pitchFamily="34" charset="-120"/>
+              </a:rPr>
+              <a:t> </a:t>
+            </a:r>
+            <a:r>
+              <a:rPr lang="en-US" sz="1100" dirty="0" err="1">
+                <a:solidFill>
+                  <a:srgbClr val="444441"/>
+                </a:solidFill>
+                <a:latin typeface="Calibri" pitchFamily="34" charset="0"/>
+                <a:ea typeface="Calibri" pitchFamily="34" charset="-122"/>
+                <a:cs typeface="Calibri" pitchFamily="34" charset="-120"/>
+              </a:rPr>
+              <a:t>reale</a:t>
+            </a:r>
+            <a:r>
+              <a:rPr lang="en-US" sz="1100" dirty="0">
+                <a:solidFill>
+                  <a:srgbClr val="444441"/>
+                </a:solidFill>
+                <a:latin typeface="Calibri" pitchFamily="34" charset="0"/>
+                <a:ea typeface="Calibri" pitchFamily="34" charset="-122"/>
+                <a:cs typeface="Calibri" pitchFamily="34" charset="-120"/>
+              </a:rPr>
+              <a:t>, </a:t>
+            </a:r>
+            <a:r>
+              <a:rPr lang="en-US" sz="1100" dirty="0" err="1">
+                <a:solidFill>
+                  <a:srgbClr val="444441"/>
+                </a:solidFill>
+                <a:latin typeface="Calibri" pitchFamily="34" charset="0"/>
+                <a:ea typeface="Calibri" pitchFamily="34" charset="-122"/>
+                <a:cs typeface="Calibri" pitchFamily="34" charset="-120"/>
+              </a:rPr>
+              <a:t>abbiamo</a:t>
+            </a:r>
+            <a:r>
+              <a:rPr lang="en-US" sz="1100" dirty="0">
+                <a:solidFill>
+                  <a:srgbClr val="444441"/>
+                </a:solidFill>
+                <a:latin typeface="Calibri" pitchFamily="34" charset="0"/>
+                <a:ea typeface="Calibri" pitchFamily="34" charset="-122"/>
+                <a:cs typeface="Calibri" pitchFamily="34" charset="-120"/>
+              </a:rPr>
+              <a:t> </a:t>
+            </a:r>
+            <a:r>
+              <a:rPr lang="en-US" sz="1100" dirty="0" err="1">
+                <a:solidFill>
+                  <a:srgbClr val="444441"/>
+                </a:solidFill>
+                <a:latin typeface="Calibri" pitchFamily="34" charset="0"/>
+                <a:ea typeface="Calibri" pitchFamily="34" charset="-122"/>
+                <a:cs typeface="Calibri" pitchFamily="34" charset="-120"/>
+              </a:rPr>
+              <a:t>utilizzato</a:t>
+            </a:r>
+            <a:r>
+              <a:rPr lang="en-US" sz="1100" dirty="0">
+                <a:solidFill>
+                  <a:srgbClr val="444441"/>
+                </a:solidFill>
+                <a:latin typeface="Calibri" pitchFamily="34" charset="0"/>
+                <a:ea typeface="Calibri" pitchFamily="34" charset="-122"/>
+                <a:cs typeface="Calibri" pitchFamily="34" charset="-120"/>
+              </a:rPr>
+              <a:t> fill_between per </a:t>
+            </a:r>
+            <a:r>
+              <a:rPr lang="en-US" sz="1100" dirty="0" err="1">
+                <a:solidFill>
+                  <a:srgbClr val="444441"/>
+                </a:solidFill>
+                <a:latin typeface="Calibri" pitchFamily="34" charset="0"/>
+                <a:ea typeface="Calibri" pitchFamily="34" charset="-122"/>
+                <a:cs typeface="Calibri" pitchFamily="34" charset="-120"/>
+              </a:rPr>
+              <a:t>l’intervallo</a:t>
+            </a:r>
+            <a:r>
+              <a:rPr lang="en-US" sz="1100" dirty="0">
+                <a:solidFill>
+                  <a:srgbClr val="444441"/>
+                </a:solidFill>
+                <a:latin typeface="Calibri" pitchFamily="34" charset="0"/>
+                <a:ea typeface="Calibri" pitchFamily="34" charset="-122"/>
+                <a:cs typeface="Calibri" pitchFamily="34" charset="-120"/>
+              </a:rPr>
+              <a:t> di confidenza al 95%.</a:t>
             </a:r>
             <a:endParaRPr lang="en-US" sz="1100" dirty="0"/>
           </a:p>
@@ -5718,7 +5861,7 @@
         </p:nvSpPr>
         <p:spPr>
           <a:xfrm>
-            <a:off x="411480" y="2971800"/>
+            <a:off x="411480" y="2964366"/>
             <a:ext cx="4069080" cy="1554480"/>
           </a:xfrm>
           <a:prstGeom prst="roundRect">
@@ -5736,13 +5879,20 @@
             <a:prstDash val="solid"/>
           </a:ln>
           <a:effectLst>
-            <a:outerShdw sx="100000" sy="100000" kx="0" ky="0" algn="bl" rotWithShape="0" blurRad="63500" dist="25400" dir="2700000">
+            <a:outerShdw blurRad="63500" dist="25400" dir="2700000" algn="bl" rotWithShape="0">
               <a:srgbClr val="000000">
                 <a:alpha val="8000"/>
               </a:srgbClr>
             </a:outerShdw>
           </a:effectLst>
         </p:spPr>
+        <p:txBody>
+          <a:bodyPr/>
+          <a:lstStyle/>
+          <a:p>
+            <a:endParaRPr lang="it-IT"/>
+          </a:p>
+        </p:txBody>
       </p:sp>
       <p:sp>
         <p:nvSpPr>
@@ -5765,7 +5915,7 @@
           <a:bodyPr wrap="square" rtlCol="0" anchor="ctr"/>
           <a:lstStyle/>
           <a:p>
-            <a:pPr indent="0" marL="0">
+            <a:pPr marL="0" indent="0">
               <a:buNone/>
             </a:pPr>
             <a:r>
@@ -5804,7 +5954,7 @@
           <a:bodyPr wrap="square" rtlCol="0" anchor="ctr"/>
           <a:lstStyle/>
           <a:p>
-            <a:pPr indent="0" marL="0">
+            <a:pPr marL="0" indent="0">
               <a:buNone/>
             </a:pPr>
             <a:r>
@@ -5848,13 +5998,20 @@
             <a:prstDash val="solid"/>
           </a:ln>
           <a:effectLst>
-            <a:outerShdw sx="100000" sy="100000" kx="0" ky="0" algn="bl" rotWithShape="0" blurRad="63500" dist="25400" dir="2700000">
+            <a:outerShdw blurRad="63500" dist="25400" dir="2700000" algn="bl" rotWithShape="0">
               <a:srgbClr val="000000">
                 <a:alpha val="8000"/>
               </a:srgbClr>
             </a:outerShdw>
           </a:effectLst>
         </p:spPr>
+        <p:txBody>
+          <a:bodyPr/>
+          <a:lstStyle/>
+          <a:p>
+            <a:endParaRPr lang="it-IT"/>
+          </a:p>
+        </p:txBody>
       </p:sp>
       <p:sp>
         <p:nvSpPr>
@@ -5877,7 +6034,7 @@
           <a:bodyPr wrap="square" rtlCol="0" anchor="ctr"/>
           <a:lstStyle/>
           <a:p>
-            <a:pPr indent="0" marL="0">
+            <a:pPr marL="0" indent="0">
               <a:buNone/>
             </a:pPr>
             <a:r>
@@ -5916,7 +6073,7 @@
           <a:bodyPr wrap="square" rtlCol="0" anchor="ctr"/>
           <a:lstStyle/>
           <a:p>
-            <a:pPr indent="0" marL="0">
+            <a:pPr marL="0" indent="0">
               <a:buNone/>
             </a:pPr>
             <a:r>
@@ -5950,6 +6107,7 @@
         <a:solidFill>
           <a:srgbClr val="2C2C2A"/>
         </a:solidFill>
+        <a:effectLst/>
       </p:bgPr>
     </p:bg>
     <p:spTree>
@@ -5987,7 +6145,7 @@
           <a:bodyPr wrap="square" rtlCol="0" anchor="ctr"/>
           <a:lstStyle/>
           <a:p>
-            <a:pPr indent="0" marL="0">
+            <a:pPr marL="0" indent="0">
               <a:buNone/>
             </a:pPr>
             <a:r>
@@ -6190,6 +6348,7 @@
         <a:solidFill>
           <a:srgbClr val="FAFAF8"/>
         </a:solidFill>
+        <a:effectLst/>
       </p:bgPr>
     </p:bg>
     <p:spTree>
@@ -6227,7 +6386,7 @@
           <a:bodyPr wrap="square" rtlCol="0" anchor="ctr"/>
           <a:lstStyle/>
           <a:p>
-            <a:pPr indent="0" marL="0">
+            <a:pPr marL="0" indent="0">
               <a:buNone/>
             </a:pPr>
             <a:r>
@@ -6266,7 +6425,7 @@
           <a:bodyPr wrap="square" rtlCol="0" anchor="ctr"/>
           <a:lstStyle/>
           <a:p>
-            <a:pPr indent="0" marL="0">
+            <a:pPr marL="0" indent="0">
               <a:buNone/>
             </a:pPr>
             <a:r>
@@ -6310,13 +6469,20 @@
             <a:prstDash val="solid"/>
           </a:ln>
           <a:effectLst>
-            <a:outerShdw sx="100000" sy="100000" kx="0" ky="0" algn="bl" rotWithShape="0" blurRad="63500" dist="25400" dir="2700000">
+            <a:outerShdw blurRad="63500" dist="25400" dir="2700000" algn="bl" rotWithShape="0">
               <a:srgbClr val="000000">
                 <a:alpha val="8000"/>
               </a:srgbClr>
             </a:outerShdw>
           </a:effectLst>
         </p:spPr>
+        <p:txBody>
+          <a:bodyPr/>
+          <a:lstStyle/>
+          <a:p>
+            <a:endParaRPr lang="it-IT"/>
+          </a:p>
+        </p:txBody>
       </p:sp>
       <p:sp>
         <p:nvSpPr>
@@ -6339,7 +6505,7 @@
           <a:bodyPr wrap="square" rtlCol="0" anchor="ctr"/>
           <a:lstStyle/>
           <a:p>
-            <a:pPr indent="0" marL="0">
+            <a:pPr marL="0" indent="0">
               <a:buNone/>
             </a:pPr>
             <a:r>
@@ -6378,7 +6544,7 @@
           <a:bodyPr wrap="square" rtlCol="0" anchor="ctr"/>
           <a:lstStyle/>
           <a:p>
-            <a:pPr indent="0" marL="0">
+            <a:pPr marL="0" indent="0">
               <a:buNone/>
             </a:pPr>
             <a:r>
@@ -6498,13 +6664,20 @@
             <a:prstDash val="solid"/>
           </a:ln>
           <a:effectLst>
-            <a:outerShdw sx="100000" sy="100000" kx="0" ky="0" algn="bl" rotWithShape="0" blurRad="63500" dist="25400" dir="2700000">
+            <a:outerShdw blurRad="63500" dist="25400" dir="2700000" algn="bl" rotWithShape="0">
               <a:srgbClr val="000000">
                 <a:alpha val="8000"/>
               </a:srgbClr>
             </a:outerShdw>
           </a:effectLst>
         </p:spPr>
+        <p:txBody>
+          <a:bodyPr/>
+          <a:lstStyle/>
+          <a:p>
+            <a:endParaRPr lang="it-IT"/>
+          </a:p>
+        </p:txBody>
       </p:sp>
       <p:sp>
         <p:nvSpPr>
@@ -6527,7 +6700,7 @@
           <a:bodyPr wrap="square" rtlCol="0" anchor="ctr"/>
           <a:lstStyle/>
           <a:p>
-            <a:pPr indent="0" marL="0">
+            <a:pPr marL="0" indent="0">
               <a:buNone/>
             </a:pPr>
             <a:r>
@@ -6566,7 +6739,7 @@
           <a:bodyPr wrap="square" rtlCol="0" anchor="ctr"/>
           <a:lstStyle/>
           <a:p>
-            <a:pPr indent="0" marL="0">
+            <a:pPr marL="0" indent="0">
               <a:buNone/>
             </a:pPr>
             <a:r>
@@ -6686,13 +6859,20 @@
             <a:prstDash val="solid"/>
           </a:ln>
           <a:effectLst>
-            <a:outerShdw sx="100000" sy="100000" kx="0" ky="0" algn="bl" rotWithShape="0" blurRad="63500" dist="25400" dir="2700000">
+            <a:outerShdw blurRad="63500" dist="25400" dir="2700000" algn="bl" rotWithShape="0">
               <a:srgbClr val="000000">
                 <a:alpha val="8000"/>
               </a:srgbClr>
             </a:outerShdw>
           </a:effectLst>
         </p:spPr>
+        <p:txBody>
+          <a:bodyPr/>
+          <a:lstStyle/>
+          <a:p>
+            <a:endParaRPr lang="it-IT"/>
+          </a:p>
+        </p:txBody>
       </p:sp>
       <p:sp>
         <p:nvSpPr>
@@ -6715,7 +6895,7 @@
           <a:bodyPr wrap="square" rtlCol="0" anchor="ctr"/>
           <a:lstStyle/>
           <a:p>
-            <a:pPr indent="0" marL="0">
+            <a:pPr marL="0" indent="0">
               <a:buNone/>
             </a:pPr>
             <a:r>
@@ -6754,7 +6934,7 @@
           <a:bodyPr wrap="square" rtlCol="0" anchor="ctr"/>
           <a:lstStyle/>
           <a:p>
-            <a:pPr indent="0" marL="0">
+            <a:pPr marL="0" indent="0">
               <a:buNone/>
             </a:pPr>
             <a:r>
@@ -6864,6 +7044,7 @@
         <a:solidFill>
           <a:srgbClr val="FAFAF8"/>
         </a:solidFill>
+        <a:effectLst/>
       </p:bgPr>
     </p:bg>
     <p:spTree>
@@ -6906,6 +7087,13 @@
             <a:prstDash val="solid"/>
           </a:ln>
         </p:spPr>
+        <p:txBody>
+          <a:bodyPr/>
+          <a:lstStyle/>
+          <a:p>
+            <a:endParaRPr lang="it-IT"/>
+          </a:p>
+        </p:txBody>
       </p:sp>
       <p:sp>
         <p:nvSpPr>
@@ -6928,7 +7116,7 @@
           <a:bodyPr wrap="square" lIns="0" tIns="0" rIns="0" bIns="0" rtlCol="0" anchor="ctr"/>
           <a:lstStyle/>
           <a:p>
-            <a:pPr algn="ctr" indent="0" marL="0">
+            <a:pPr marL="0" indent="0" algn="ctr">
               <a:buNone/>
             </a:pPr>
             <a:r>
@@ -6967,7 +7155,7 @@
           <a:bodyPr wrap="square" rtlCol="0" anchor="ctr"/>
           <a:lstStyle/>
           <a:p>
-            <a:pPr indent="0" marL="0">
+            <a:pPr marL="0" indent="0">
               <a:buNone/>
             </a:pPr>
             <a:r>
@@ -7011,13 +7199,20 @@
             <a:prstDash val="solid"/>
           </a:ln>
           <a:effectLst>
-            <a:outerShdw sx="100000" sy="100000" kx="0" ky="0" algn="bl" rotWithShape="0" blurRad="63500" dist="25400" dir="2700000">
+            <a:outerShdw blurRad="63500" dist="25400" dir="2700000" algn="bl" rotWithShape="0">
               <a:srgbClr val="000000">
                 <a:alpha val="8000"/>
               </a:srgbClr>
             </a:outerShdw>
           </a:effectLst>
         </p:spPr>
+        <p:txBody>
+          <a:bodyPr/>
+          <a:lstStyle/>
+          <a:p>
+            <a:endParaRPr lang="it-IT"/>
+          </a:p>
+        </p:txBody>
       </p:sp>
       <p:sp>
         <p:nvSpPr>
@@ -7040,7 +7235,7 @@
           <a:bodyPr wrap="square" rtlCol="0" anchor="ctr"/>
           <a:lstStyle/>
           <a:p>
-            <a:pPr indent="0" marL="0">
+            <a:pPr marL="0" indent="0">
               <a:buNone/>
             </a:pPr>
             <a:r>
@@ -7079,7 +7274,7 @@
           <a:bodyPr wrap="square" rtlCol="0" anchor="ctr"/>
           <a:lstStyle/>
           <a:p>
-            <a:pPr indent="0" marL="0">
+            <a:pPr marL="0" indent="0">
               <a:buNone/>
             </a:pPr>
             <a:r>
@@ -7123,13 +7318,20 @@
             <a:prstDash val="solid"/>
           </a:ln>
           <a:effectLst>
-            <a:outerShdw sx="100000" sy="100000" kx="0" ky="0" algn="bl" rotWithShape="0" blurRad="63500" dist="25400" dir="2700000">
+            <a:outerShdw blurRad="63500" dist="25400" dir="2700000" algn="bl" rotWithShape="0">
               <a:srgbClr val="000000">
                 <a:alpha val="8000"/>
               </a:srgbClr>
             </a:outerShdw>
           </a:effectLst>
         </p:spPr>
+        <p:txBody>
+          <a:bodyPr/>
+          <a:lstStyle/>
+          <a:p>
+            <a:endParaRPr lang="it-IT"/>
+          </a:p>
+        </p:txBody>
       </p:sp>
       <p:sp>
         <p:nvSpPr>
@@ -7152,7 +7354,7 @@
           <a:bodyPr wrap="square" rtlCol="0" anchor="ctr"/>
           <a:lstStyle/>
           <a:p>
-            <a:pPr indent="0" marL="0">
+            <a:pPr marL="0" indent="0">
               <a:buNone/>
             </a:pPr>
             <a:r>
@@ -7191,7 +7393,7 @@
           <a:bodyPr wrap="square" rtlCol="0" anchor="ctr"/>
           <a:lstStyle/>
           <a:p>
-            <a:pPr indent="0" marL="0">
+            <a:pPr marL="0" indent="0">
               <a:buNone/>
             </a:pPr>
             <a:r>
@@ -7203,7 +7405,7 @@
                 <a:ea typeface="Calibri" pitchFamily="34" charset="-122"/>
                 <a:cs typeface="Calibri" pitchFamily="34" charset="-120"/>
               </a:rPr>
-              <a:t>anni di copertura (1921–2020)</a:t>
+              <a:t>anni (1921–2020)</a:t>
             </a:r>
             <a:endParaRPr lang="en-US" sz="1200" dirty="0"/>
           </a:p>
@@ -7235,13 +7437,20 @@
             <a:prstDash val="solid"/>
           </a:ln>
           <a:effectLst>
-            <a:outerShdw sx="100000" sy="100000" kx="0" ky="0" algn="bl" rotWithShape="0" blurRad="63500" dist="25400" dir="2700000">
+            <a:outerShdw blurRad="63500" dist="25400" dir="2700000" algn="bl" rotWithShape="0">
               <a:srgbClr val="000000">
                 <a:alpha val="8000"/>
               </a:srgbClr>
             </a:outerShdw>
           </a:effectLst>
         </p:spPr>
+        <p:txBody>
+          <a:bodyPr/>
+          <a:lstStyle/>
+          <a:p>
+            <a:endParaRPr lang="it-IT"/>
+          </a:p>
+        </p:txBody>
       </p:sp>
       <p:sp>
         <p:nvSpPr>
@@ -7264,7 +7473,7 @@
           <a:bodyPr wrap="square" rtlCol="0" anchor="ctr"/>
           <a:lstStyle/>
           <a:p>
-            <a:pPr indent="0" marL="0">
+            <a:pPr marL="0" indent="0">
               <a:buNone/>
             </a:pPr>
             <a:r>
@@ -7303,7 +7512,7 @@
           <a:bodyPr wrap="square" rtlCol="0" anchor="ctr"/>
           <a:lstStyle/>
           <a:p>
-            <a:pPr indent="0" marL="0">
+            <a:pPr marL="0" indent="0">
               <a:buNone/>
             </a:pPr>
             <a:r>
@@ -7347,13 +7556,20 @@
             <a:prstDash val="solid"/>
           </a:ln>
           <a:effectLst>
-            <a:outerShdw sx="100000" sy="100000" kx="0" ky="0" algn="bl" rotWithShape="0" blurRad="63500" dist="25400" dir="2700000">
+            <a:outerShdw blurRad="63500" dist="25400" dir="2700000" algn="bl" rotWithShape="0">
               <a:srgbClr val="000000">
                 <a:alpha val="8000"/>
               </a:srgbClr>
             </a:outerShdw>
           </a:effectLst>
         </p:spPr>
+        <p:txBody>
+          <a:bodyPr/>
+          <a:lstStyle/>
+          <a:p>
+            <a:endParaRPr lang="it-IT"/>
+          </a:p>
+        </p:txBody>
       </p:sp>
       <p:sp>
         <p:nvSpPr>
@@ -7376,7 +7592,7 @@
           <a:bodyPr wrap="square" rtlCol="0" anchor="ctr"/>
           <a:lstStyle/>
           <a:p>
-            <a:pPr algn="ctr" indent="0" marL="0">
+            <a:pPr marL="0" indent="0" algn="ctr">
               <a:buNone/>
             </a:pPr>
             <a:r>
@@ -7393,7 +7609,7 @@
             <a:endParaRPr lang="en-US" sz="1000" dirty="0"/>
           </a:p>
           <a:p>
-            <a:pPr algn="ctr" indent="0" marL="0">
+            <a:pPr marL="0" indent="0" algn="ctr">
               <a:buNone/>
             </a:pPr>
             <a:r>
@@ -7432,7 +7648,7 @@
           <a:bodyPr wrap="square" rtlCol="0" anchor="ctr"/>
           <a:lstStyle/>
           <a:p>
-            <a:pPr algn="l" indent="0" marL="0">
+            <a:pPr marL="0" indent="0" algn="l">
               <a:buNone/>
             </a:pPr>
             <a:r>
@@ -7444,7 +7660,7 @@
                 <a:ea typeface="Calibri" pitchFamily="34" charset="-122"/>
                 <a:cs typeface="Calibri" pitchFamily="34" charset="-120"/>
               </a:rPr>
-              <a:t>Stephen Few · Table Design: numeri allineati a destra, niente griglie interne · Lie Factor = 0</a:t>
+              <a:t>Stephen Few · Table Design: numeri allineati a destra, niente griglie interne · Lie Factor = 1</a:t>
             </a:r>
             <a:endParaRPr lang="en-US" sz="950" dirty="0"/>
           </a:p>
@@ -7466,6 +7682,7 @@
         <a:solidFill>
           <a:srgbClr val="2C2C2A"/>
         </a:solidFill>
+        <a:effectLst/>
       </p:bgPr>
     </p:bg>
     <p:spTree>
@@ -7508,6 +7725,13 @@
             <a:prstDash val="solid"/>
           </a:ln>
         </p:spPr>
+        <p:txBody>
+          <a:bodyPr/>
+          <a:lstStyle/>
+          <a:p>
+            <a:endParaRPr lang="it-IT"/>
+          </a:p>
+        </p:txBody>
       </p:sp>
       <p:sp>
         <p:nvSpPr>
@@ -7530,7 +7754,7 @@
           <a:bodyPr wrap="square" lIns="0" tIns="0" rIns="0" bIns="0" rtlCol="0" anchor="ctr"/>
           <a:lstStyle/>
           <a:p>
-            <a:pPr algn="ctr" indent="0" marL="0">
+            <a:pPr marL="0" indent="0" algn="ctr">
               <a:buNone/>
             </a:pPr>
             <a:r>
@@ -7569,7 +7793,7 @@
           <a:bodyPr wrap="square" rtlCol="0" anchor="ctr"/>
           <a:lstStyle/>
           <a:p>
-            <a:pPr indent="0" marL="0">
+            <a:pPr marL="0" indent="0">
               <a:buNone/>
             </a:pPr>
             <a:r>
@@ -7608,7 +7832,7 @@
           <a:bodyPr wrap="square" rtlCol="0" anchor="ctr"/>
           <a:lstStyle/>
           <a:p>
-            <a:pPr indent="0" marL="0">
+            <a:pPr marL="0" indent="0">
               <a:buNone/>
             </a:pPr>
             <a:r>
@@ -7642,6 +7866,7 @@
         <a:solidFill>
           <a:srgbClr val="FAFAF8"/>
         </a:solidFill>
+        <a:effectLst/>
       </p:bgPr>
     </p:bg>
     <p:spTree>
@@ -7684,6 +7909,13 @@
             <a:prstDash val="solid"/>
           </a:ln>
         </p:spPr>
+        <p:txBody>
+          <a:bodyPr/>
+          <a:lstStyle/>
+          <a:p>
+            <a:endParaRPr lang="it-IT"/>
+          </a:p>
+        </p:txBody>
       </p:sp>
       <p:sp>
         <p:nvSpPr>
@@ -7706,7 +7938,7 @@
           <a:bodyPr wrap="square" lIns="0" tIns="0" rIns="0" bIns="0" rtlCol="0" anchor="ctr"/>
           <a:lstStyle/>
           <a:p>
-            <a:pPr algn="ctr" indent="0" marL="0">
+            <a:pPr marL="0" indent="0" algn="ctr">
               <a:buNone/>
             </a:pPr>
             <a:r>
@@ -7745,7 +7977,7 @@
           <a:bodyPr wrap="square" rtlCol="0" anchor="ctr"/>
           <a:lstStyle/>
           <a:p>
-            <a:pPr indent="0" marL="0">
+            <a:pPr marL="0" indent="0">
               <a:buNone/>
             </a:pPr>
             <a:r>
@@ -7789,6 +8021,13 @@
             <a:prstDash val="solid"/>
           </a:ln>
         </p:spPr>
+        <p:txBody>
+          <a:bodyPr/>
+          <a:lstStyle/>
+          <a:p>
+            <a:endParaRPr lang="it-IT"/>
+          </a:p>
+        </p:txBody>
       </p:sp>
       <p:sp>
         <p:nvSpPr>
@@ -7811,7 +8050,7 @@
           <a:bodyPr wrap="square" rtlCol="0" anchor="ctr"/>
           <a:lstStyle/>
           <a:p>
-            <a:pPr indent="0" marL="0">
+            <a:pPr marL="0" indent="0">
               <a:buNone/>
             </a:pPr>
             <a:r>
@@ -7828,7 +8067,7 @@
             <a:endParaRPr lang="en-US" sz="1600" dirty="0"/>
           </a:p>
           <a:p>
-            <a:pPr indent="0" marL="0">
+            <a:pPr marL="0" indent="0">
               <a:buNone/>
             </a:pPr>
             <a:r>
@@ -7992,13 +8231,20 @@
             <a:prstDash val="solid"/>
           </a:ln>
           <a:effectLst>
-            <a:outerShdw sx="100000" sy="100000" kx="0" ky="0" algn="bl" rotWithShape="0" blurRad="63500" dist="25400" dir="2700000">
+            <a:outerShdw blurRad="63500" dist="25400" dir="2700000" algn="bl" rotWithShape="0">
               <a:srgbClr val="000000">
                 <a:alpha val="8000"/>
               </a:srgbClr>
             </a:outerShdw>
           </a:effectLst>
         </p:spPr>
+        <p:txBody>
+          <a:bodyPr/>
+          <a:lstStyle/>
+          <a:p>
+            <a:endParaRPr lang="it-IT"/>
+          </a:p>
+        </p:txBody>
       </p:sp>
       <p:sp>
         <p:nvSpPr>
@@ -8021,7 +8267,7 @@
           <a:bodyPr wrap="square" rtlCol="0" anchor="ctr"/>
           <a:lstStyle/>
           <a:p>
-            <a:pPr algn="ctr" indent="0" marL="0">
+            <a:pPr marL="0" indent="0" algn="ctr">
               <a:buNone/>
             </a:pPr>
             <a:r>
@@ -8038,7 +8284,7 @@
             <a:endParaRPr lang="en-US" sz="1000" dirty="0"/>
           </a:p>
           <a:p>
-            <a:pPr algn="ctr" indent="0" marL="0">
+            <a:pPr marL="0" indent="0" algn="ctr">
               <a:buNone/>
             </a:pPr>
             <a:r>
@@ -8077,7 +8323,7 @@
           <a:bodyPr wrap="square" rtlCol="0" anchor="ctr"/>
           <a:lstStyle/>
           <a:p>
-            <a:pPr algn="l" indent="0" marL="0">
+            <a:pPr marL="0" indent="0" algn="l">
               <a:buNone/>
             </a:pPr>
             <a:r>
@@ -8111,6 +8357,7 @@
         <a:solidFill>
           <a:srgbClr val="FAFAF8"/>
         </a:solidFill>
+        <a:effectLst/>
       </p:bgPr>
     </p:bg>
     <p:spTree>
@@ -8153,6 +8400,13 @@
             <a:prstDash val="solid"/>
           </a:ln>
         </p:spPr>
+        <p:txBody>
+          <a:bodyPr/>
+          <a:lstStyle/>
+          <a:p>
+            <a:endParaRPr lang="it-IT"/>
+          </a:p>
+        </p:txBody>
       </p:sp>
       <p:sp>
         <p:nvSpPr>
@@ -8175,7 +8429,7 @@
           <a:bodyPr wrap="square" lIns="0" tIns="0" rIns="0" bIns="0" rtlCol="0" anchor="ctr"/>
           <a:lstStyle/>
           <a:p>
-            <a:pPr algn="ctr" indent="0" marL="0">
+            <a:pPr marL="0" indent="0" algn="ctr">
               <a:buNone/>
             </a:pPr>
             <a:r>
@@ -8214,7 +8468,7 @@
           <a:bodyPr wrap="square" rtlCol="0" anchor="ctr"/>
           <a:lstStyle/>
           <a:p>
-            <a:pPr indent="0" marL="0">
+            <a:pPr marL="0" indent="0">
               <a:buNone/>
             </a:pPr>
             <a:r>
@@ -8258,13 +8512,20 @@
             <a:prstDash val="solid"/>
           </a:ln>
           <a:effectLst>
-            <a:outerShdw sx="100000" sy="100000" kx="0" ky="0" algn="bl" rotWithShape="0" blurRad="63500" dist="25400" dir="2700000">
+            <a:outerShdw blurRad="63500" dist="25400" dir="2700000" algn="bl" rotWithShape="0">
               <a:srgbClr val="000000">
                 <a:alpha val="8000"/>
               </a:srgbClr>
             </a:outerShdw>
           </a:effectLst>
         </p:spPr>
+        <p:txBody>
+          <a:bodyPr/>
+          <a:lstStyle/>
+          <a:p>
+            <a:endParaRPr lang="it-IT"/>
+          </a:p>
+        </p:txBody>
       </p:sp>
       <p:sp>
         <p:nvSpPr>
@@ -8287,7 +8548,7 @@
           <a:bodyPr wrap="square" rtlCol="0" anchor="ctr"/>
           <a:lstStyle/>
           <a:p>
-            <a:pPr algn="ctr" indent="0" marL="0">
+            <a:pPr marL="0" indent="0" algn="ctr">
               <a:buNone/>
             </a:pPr>
             <a:r>
@@ -8304,7 +8565,7 @@
             <a:endParaRPr lang="en-US" sz="1000" dirty="0"/>
           </a:p>
           <a:p>
-            <a:pPr algn="ctr" indent="0" marL="0">
+            <a:pPr marL="0" indent="0" algn="ctr">
               <a:buNone/>
             </a:pPr>
             <a:r>
@@ -8343,7 +8604,7 @@
           <a:bodyPr wrap="square" rtlCol="0" anchor="ctr"/>
           <a:lstStyle/>
           <a:p>
-            <a:pPr algn="l" indent="0" marL="0">
+            <a:pPr marL="0" indent="0" algn="l">
               <a:buNone/>
             </a:pPr>
             <a:r>
@@ -8377,6 +8638,7 @@
         <a:solidFill>
           <a:srgbClr val="2C2C2A"/>
         </a:solidFill>
+        <a:effectLst/>
       </p:bgPr>
     </p:bg>
     <p:spTree>
@@ -8419,6 +8681,13 @@
             <a:prstDash val="solid"/>
           </a:ln>
         </p:spPr>
+        <p:txBody>
+          <a:bodyPr/>
+          <a:lstStyle/>
+          <a:p>
+            <a:endParaRPr lang="it-IT"/>
+          </a:p>
+        </p:txBody>
       </p:sp>
       <p:sp>
         <p:nvSpPr>
@@ -8441,7 +8710,7 @@
           <a:bodyPr wrap="square" lIns="0" tIns="0" rIns="0" bIns="0" rtlCol="0" anchor="ctr"/>
           <a:lstStyle/>
           <a:p>
-            <a:pPr algn="ctr" indent="0" marL="0">
+            <a:pPr marL="0" indent="0" algn="ctr">
               <a:buNone/>
             </a:pPr>
             <a:r>
@@ -8480,7 +8749,7 @@
           <a:bodyPr wrap="square" rtlCol="0" anchor="ctr"/>
           <a:lstStyle/>
           <a:p>
-            <a:pPr indent="0" marL="0">
+            <a:pPr marL="0" indent="0">
               <a:buNone/>
             </a:pPr>
             <a:r>
@@ -8519,7 +8788,7 @@
           <a:bodyPr wrap="square" rtlCol="0" anchor="ctr"/>
           <a:lstStyle/>
           <a:p>
-            <a:pPr indent="0" marL="0">
+            <a:pPr marL="0" indent="0">
               <a:buNone/>
             </a:pPr>
             <a:r>
@@ -8553,6 +8822,7 @@
         <a:solidFill>
           <a:srgbClr val="FAFAF8"/>
         </a:solidFill>
+        <a:effectLst/>
       </p:bgPr>
     </p:bg>
     <p:spTree>
@@ -8595,6 +8865,13 @@
             <a:prstDash val="solid"/>
           </a:ln>
         </p:spPr>
+        <p:txBody>
+          <a:bodyPr/>
+          <a:lstStyle/>
+          <a:p>
+            <a:endParaRPr lang="it-IT"/>
+          </a:p>
+        </p:txBody>
       </p:sp>
       <p:sp>
         <p:nvSpPr>
@@ -8617,7 +8894,7 @@
           <a:bodyPr wrap="square" lIns="0" tIns="0" rIns="0" bIns="0" rtlCol="0" anchor="ctr"/>
           <a:lstStyle/>
           <a:p>
-            <a:pPr algn="ctr" indent="0" marL="0">
+            <a:pPr marL="0" indent="0" algn="ctr">
               <a:buNone/>
             </a:pPr>
             <a:r>
@@ -8656,7 +8933,7 @@
           <a:bodyPr wrap="square" rtlCol="0" anchor="ctr"/>
           <a:lstStyle/>
           <a:p>
-            <a:pPr indent="0" marL="0">
+            <a:pPr marL="0" indent="0">
               <a:buNone/>
             </a:pPr>
             <a:r>
@@ -8700,13 +8977,20 @@
             <a:prstDash val="solid"/>
           </a:ln>
           <a:effectLst>
-            <a:outerShdw sx="100000" sy="100000" kx="0" ky="0" algn="bl" rotWithShape="0" blurRad="63500" dist="25400" dir="2700000">
+            <a:outerShdw blurRad="63500" dist="25400" dir="2700000" algn="bl" rotWithShape="0">
               <a:srgbClr val="000000">
                 <a:alpha val="8000"/>
               </a:srgbClr>
             </a:outerShdw>
           </a:effectLst>
         </p:spPr>
+        <p:txBody>
+          <a:bodyPr/>
+          <a:lstStyle/>
+          <a:p>
+            <a:endParaRPr lang="it-IT"/>
+          </a:p>
+        </p:txBody>
       </p:sp>
       <p:sp>
         <p:nvSpPr>
@@ -8729,7 +9013,7 @@
           <a:bodyPr wrap="square" rtlCol="0" anchor="ctr"/>
           <a:lstStyle/>
           <a:p>
-            <a:pPr algn="ctr" indent="0" marL="0">
+            <a:pPr marL="0" indent="0" algn="ctr">
               <a:buNone/>
             </a:pPr>
             <a:r>
@@ -8746,7 +9030,7 @@
             <a:endParaRPr lang="en-US" sz="1000" dirty="0"/>
           </a:p>
           <a:p>
-            <a:pPr algn="ctr" indent="0" marL="0">
+            <a:pPr marL="0" indent="0" algn="ctr">
               <a:buNone/>
             </a:pPr>
             <a:r>
@@ -8785,7 +9069,7 @@
           <a:bodyPr wrap="square" rtlCol="0" anchor="ctr"/>
           <a:lstStyle/>
           <a:p>
-            <a:pPr algn="l" indent="0" marL="0">
+            <a:pPr marL="0" indent="0" algn="l">
               <a:buNone/>
             </a:pPr>
             <a:r>
@@ -8819,6 +9103,7 @@
         <a:solidFill>
           <a:srgbClr val="FAFAF8"/>
         </a:solidFill>
+        <a:effectLst/>
       </p:bgPr>
     </p:bg>
     <p:spTree>
@@ -8861,6 +9146,13 @@
             <a:prstDash val="solid"/>
           </a:ln>
         </p:spPr>
+        <p:txBody>
+          <a:bodyPr/>
+          <a:lstStyle/>
+          <a:p>
+            <a:endParaRPr lang="it-IT"/>
+          </a:p>
+        </p:txBody>
       </p:sp>
       <p:sp>
         <p:nvSpPr>
@@ -8883,7 +9175,7 @@
           <a:bodyPr wrap="square" lIns="0" tIns="0" rIns="0" bIns="0" rtlCol="0" anchor="ctr"/>
           <a:lstStyle/>
           <a:p>
-            <a:pPr algn="ctr" indent="0" marL="0">
+            <a:pPr marL="0" indent="0" algn="ctr">
               <a:buNone/>
             </a:pPr>
             <a:r>
@@ -8922,7 +9214,7 @@
           <a:bodyPr wrap="square" rtlCol="0" anchor="ctr"/>
           <a:lstStyle/>
           <a:p>
-            <a:pPr indent="0" marL="0">
+            <a:pPr marL="0" indent="0">
               <a:buNone/>
             </a:pPr>
             <a:r>
@@ -8966,13 +9258,20 @@
             <a:prstDash val="solid"/>
           </a:ln>
           <a:effectLst>
-            <a:outerShdw sx="100000" sy="100000" kx="0" ky="0" algn="bl" rotWithShape="0" blurRad="63500" dist="25400" dir="2700000">
+            <a:outerShdw blurRad="63500" dist="25400" dir="2700000" algn="bl" rotWithShape="0">
               <a:srgbClr val="000000">
                 <a:alpha val="8000"/>
               </a:srgbClr>
             </a:outerShdw>
           </a:effectLst>
         </p:spPr>
+        <p:txBody>
+          <a:bodyPr/>
+          <a:lstStyle/>
+          <a:p>
+            <a:endParaRPr lang="it-IT"/>
+          </a:p>
+        </p:txBody>
       </p:sp>
       <p:sp>
         <p:nvSpPr>
@@ -8995,7 +9294,7 @@
           <a:bodyPr wrap="square" rtlCol="0" anchor="ctr"/>
           <a:lstStyle/>
           <a:p>
-            <a:pPr algn="ctr" indent="0" marL="0">
+            <a:pPr marL="0" indent="0" algn="ctr">
               <a:buNone/>
             </a:pPr>
             <a:r>
@@ -9012,7 +9311,7 @@
             <a:endParaRPr lang="en-US" sz="1000" dirty="0"/>
           </a:p>
           <a:p>
-            <a:pPr algn="ctr" indent="0" marL="0">
+            <a:pPr marL="0" indent="0" algn="ctr">
               <a:buNone/>
             </a:pPr>
             <a:r>
@@ -9051,7 +9350,7 @@
           <a:bodyPr wrap="square" rtlCol="0" anchor="ctr"/>
           <a:lstStyle/>
           <a:p>
-            <a:pPr algn="l" indent="0" marL="0">
+            <a:pPr marL="0" indent="0" algn="l">
               <a:buNone/>
             </a:pPr>
             <a:r>
@@ -9370,4 +9669,319 @@
     </a:ext>
   </a:extLst>
 </a:theme>
+</file>
+
+<file path=ppt/theme/theme2.xml><?xml version="1.0" encoding="utf-8"?>
+<a:theme xmlns:a="http://schemas.openxmlformats.org/drawingml/2006/main" name="Tema di Office">
+  <a:themeElements>
+    <a:clrScheme name="Office">
+      <a:dk1>
+        <a:sysClr val="windowText" lastClr="000000"/>
+      </a:dk1>
+      <a:lt1>
+        <a:sysClr val="window" lastClr="FFFFFF"/>
+      </a:lt1>
+      <a:dk2>
+        <a:srgbClr val="0E2841"/>
+      </a:dk2>
+      <a:lt2>
+        <a:srgbClr val="E8E8E8"/>
+      </a:lt2>
+      <a:accent1>
+        <a:srgbClr val="156082"/>
+      </a:accent1>
+      <a:accent2>
+        <a:srgbClr val="E97132"/>
+      </a:accent2>
+      <a:accent3>
+        <a:srgbClr val="196B24"/>
+      </a:accent3>
+      <a:accent4>
+        <a:srgbClr val="0F9ED5"/>
+      </a:accent4>
+      <a:accent5>
+        <a:srgbClr val="A02B93"/>
+      </a:accent5>
+      <a:accent6>
+        <a:srgbClr val="4EA72E"/>
+      </a:accent6>
+      <a:hlink>
+        <a:srgbClr val="467886"/>
+      </a:hlink>
+      <a:folHlink>
+        <a:srgbClr val="96607D"/>
+      </a:folHlink>
+    </a:clrScheme>
+    <a:fontScheme name="Office">
+      <a:majorFont>
+        <a:latin typeface="Aptos Display" panose="02110004020202020204"/>
+        <a:ea typeface=""/>
+        <a:cs typeface=""/>
+        <a:font script="Jpan" typeface="游ゴシック Light"/>
+        <a:font script="Hang" typeface="맑은 고딕"/>
+        <a:font script="Hans" typeface="等线 Light"/>
+        <a:font script="Hant" typeface="新細明體"/>
+        <a:font script="Arab" typeface="Times New Roman"/>
+        <a:font script="Hebr" typeface="Times New Roman"/>
+        <a:font script="Thai" typeface="Angsana New"/>
+        <a:font script="Ethi" typeface="Nyala"/>
+        <a:font script="Beng" typeface="Vrinda"/>
+        <a:font script="Gujr" typeface="Shruti"/>
+        <a:font script="Khmr" typeface="MoolBoran"/>
+        <a:font script="Knda" typeface="Tunga"/>
+        <a:font script="Guru" typeface="Raavi"/>
+        <a:font script="Cans" typeface="Euphemia"/>
+        <a:font script="Cher" typeface="Plantagenet Cherokee"/>
+        <a:font script="Yiii" typeface="Microsoft Yi Baiti"/>
+        <a:font script="Tibt" typeface="Microsoft Himalaya"/>
+        <a:font script="Thaa" typeface="MV Boli"/>
+        <a:font script="Deva" typeface="Mangal"/>
+        <a:font script="Telu" typeface="Gautami"/>
+        <a:font script="Taml" typeface="Latha"/>
+        <a:font script="Syrc" typeface="Estrangelo Edessa"/>
+        <a:font script="Orya" typeface="Kalinga"/>
+        <a:font script="Mlym" typeface="Kartika"/>
+        <a:font script="Laoo" typeface="DokChampa"/>
+        <a:font script="Sinh" typeface="Iskoola Pota"/>
+        <a:font script="Mong" typeface="Mongolian Baiti"/>
+        <a:font script="Viet" typeface="Times New Roman"/>
+        <a:font script="Uigh" typeface="Microsoft Uighur"/>
+        <a:font script="Geor" typeface="Sylfaen"/>
+        <a:font script="Armn" typeface="Arial"/>
+        <a:font script="Bugi" typeface="Leelawadee UI"/>
+        <a:font script="Bopo" typeface="Microsoft JhengHei"/>
+        <a:font script="Java" typeface="Javanese Text"/>
+        <a:font script="Lisu" typeface="Segoe UI"/>
+        <a:font script="Mymr" typeface="Myanmar Text"/>
+        <a:font script="Nkoo" typeface="Ebrima"/>
+        <a:font script="Olck" typeface="Nirmala UI"/>
+        <a:font script="Osma" typeface="Ebrima"/>
+        <a:font script="Phag" typeface="Phagspa"/>
+        <a:font script="Syrn" typeface="Estrangelo Edessa"/>
+        <a:font script="Syrj" typeface="Estrangelo Edessa"/>
+        <a:font script="Syre" typeface="Estrangelo Edessa"/>
+        <a:font script="Sora" typeface="Nirmala UI"/>
+        <a:font script="Tale" typeface="Microsoft Tai Le"/>
+        <a:font script="Talu" typeface="Microsoft New Tai Lue"/>
+        <a:font script="Tfng" typeface="Ebrima"/>
+      </a:majorFont>
+      <a:minorFont>
+        <a:latin typeface="Aptos" panose="02110004020202020204"/>
+        <a:ea typeface=""/>
+        <a:cs typeface=""/>
+        <a:font script="Jpan" typeface="游ゴシック"/>
+        <a:font script="Hang" typeface="맑은 고딕"/>
+        <a:font script="Hans" typeface="等线"/>
+        <a:font script="Hant" typeface="新細明體"/>
+        <a:font script="Arab" typeface="Arial"/>
+        <a:font script="Hebr" typeface="Arial"/>
+        <a:font script="Thai" typeface="Cordia New"/>
+        <a:font script="Ethi" typeface="Nyala"/>
+        <a:font script="Beng" typeface="Vrinda"/>
+        <a:font script="Gujr" typeface="Shruti"/>
+        <a:font script="Khmr" typeface="DaunPenh"/>
+        <a:font script="Knda" typeface="Tunga"/>
+        <a:font script="Guru" typeface="Raavi"/>
+        <a:font script="Cans" typeface="Euphemia"/>
+        <a:font script="Cher" typeface="Plantagenet Cherokee"/>
+        <a:font script="Yiii" typeface="Microsoft Yi Baiti"/>
+        <a:font script="Tibt" typeface="Microsoft Himalaya"/>
+        <a:font script="Thaa" typeface="MV Boli"/>
+        <a:font script="Deva" typeface="Mangal"/>
+        <a:font script="Telu" typeface="Gautami"/>
+        <a:font script="Taml" typeface="Latha"/>
+        <a:font script="Syrc" typeface="Estrangelo Edessa"/>
+        <a:font script="Orya" typeface="Kalinga"/>
+        <a:font script="Mlym" typeface="Kartika"/>
+        <a:font script="Laoo" typeface="DokChampa"/>
+        <a:font script="Sinh" typeface="Iskoola Pota"/>
+        <a:font script="Mong" typeface="Mongolian Baiti"/>
+        <a:font script="Viet" typeface="Arial"/>
+        <a:font script="Uigh" typeface="Microsoft Uighur"/>
+        <a:font script="Geor" typeface="Sylfaen"/>
+        <a:font script="Armn" typeface="Arial"/>
+        <a:font script="Bugi" typeface="Leelawadee UI"/>
+        <a:font script="Bopo" typeface="Microsoft JhengHei"/>
+        <a:font script="Java" typeface="Javanese Text"/>
+        <a:font script="Lisu" typeface="Segoe UI"/>
+        <a:font script="Mymr" typeface="Myanmar Text"/>
+        <a:font script="Nkoo" typeface="Ebrima"/>
+        <a:font script="Olck" typeface="Nirmala UI"/>
+        <a:font script="Osma" typeface="Ebrima"/>
+        <a:font script="Phag" typeface="Phagspa"/>
+        <a:font script="Syrn" typeface="Estrangelo Edessa"/>
+        <a:font script="Syrj" typeface="Estrangelo Edessa"/>
+        <a:font script="Syre" typeface="Estrangelo Edessa"/>
+        <a:font script="Sora" typeface="Nirmala UI"/>
+        <a:font script="Tale" typeface="Microsoft Tai Le"/>
+        <a:font script="Talu" typeface="Microsoft New Tai Lue"/>
+        <a:font script="Tfng" typeface="Ebrima"/>
+      </a:minorFont>
+    </a:fontScheme>
+    <a:fmtScheme name="Office">
+      <a:fillStyleLst>
+        <a:solidFill>
+          <a:schemeClr val="phClr"/>
+        </a:solidFill>
+        <a:gradFill rotWithShape="1">
+          <a:gsLst>
+            <a:gs pos="0">
+              <a:schemeClr val="phClr">
+                <a:lumMod val="110000"/>
+                <a:satMod val="105000"/>
+                <a:tint val="67000"/>
+              </a:schemeClr>
+            </a:gs>
+            <a:gs pos="50000">
+              <a:schemeClr val="phClr">
+                <a:lumMod val="105000"/>
+                <a:satMod val="103000"/>
+                <a:tint val="73000"/>
+              </a:schemeClr>
+            </a:gs>
+            <a:gs pos="100000">
+              <a:schemeClr val="phClr">
+                <a:lumMod val="105000"/>
+                <a:satMod val="109000"/>
+                <a:tint val="81000"/>
+              </a:schemeClr>
+            </a:gs>
+          </a:gsLst>
+          <a:lin ang="5400000" scaled="0"/>
+        </a:gradFill>
+        <a:gradFill rotWithShape="1">
+          <a:gsLst>
+            <a:gs pos="0">
+              <a:schemeClr val="phClr">
+                <a:satMod val="103000"/>
+                <a:lumMod val="102000"/>
+                <a:tint val="94000"/>
+              </a:schemeClr>
+            </a:gs>
+            <a:gs pos="50000">
+              <a:schemeClr val="phClr">
+                <a:satMod val="110000"/>
+                <a:lumMod val="100000"/>
+                <a:shade val="100000"/>
+              </a:schemeClr>
+            </a:gs>
+            <a:gs pos="100000">
+              <a:schemeClr val="phClr">
+                <a:lumMod val="99000"/>
+                <a:satMod val="120000"/>
+                <a:shade val="78000"/>
+              </a:schemeClr>
+            </a:gs>
+          </a:gsLst>
+          <a:lin ang="5400000" scaled="0"/>
+        </a:gradFill>
+      </a:fillStyleLst>
+      <a:lnStyleLst>
+        <a:ln w="12700" cap="flat" cmpd="sng" algn="ctr">
+          <a:solidFill>
+            <a:schemeClr val="phClr"/>
+          </a:solidFill>
+          <a:prstDash val="solid"/>
+          <a:miter lim="800000"/>
+        </a:ln>
+        <a:ln w="19050" cap="flat" cmpd="sng" algn="ctr">
+          <a:solidFill>
+            <a:schemeClr val="phClr"/>
+          </a:solidFill>
+          <a:prstDash val="solid"/>
+          <a:miter lim="800000"/>
+        </a:ln>
+        <a:ln w="25400" cap="flat" cmpd="sng" algn="ctr">
+          <a:solidFill>
+            <a:schemeClr val="phClr"/>
+          </a:solidFill>
+          <a:prstDash val="solid"/>
+          <a:miter lim="800000"/>
+        </a:ln>
+      </a:lnStyleLst>
+      <a:effectStyleLst>
+        <a:effectStyle>
+          <a:effectLst/>
+        </a:effectStyle>
+        <a:effectStyle>
+          <a:effectLst/>
+        </a:effectStyle>
+        <a:effectStyle>
+          <a:effectLst>
+            <a:outerShdw blurRad="57150" dist="19050" dir="5400000" algn="ctr" rotWithShape="0">
+              <a:srgbClr val="000000">
+                <a:alpha val="63000"/>
+              </a:srgbClr>
+            </a:outerShdw>
+          </a:effectLst>
+        </a:effectStyle>
+      </a:effectStyleLst>
+      <a:bgFillStyleLst>
+        <a:solidFill>
+          <a:schemeClr val="phClr"/>
+        </a:solidFill>
+        <a:solidFill>
+          <a:schemeClr val="phClr">
+            <a:tint val="95000"/>
+            <a:satMod val="170000"/>
+          </a:schemeClr>
+        </a:solidFill>
+        <a:gradFill rotWithShape="1">
+          <a:gsLst>
+            <a:gs pos="0">
+              <a:schemeClr val="phClr">
+                <a:tint val="93000"/>
+                <a:satMod val="150000"/>
+                <a:shade val="98000"/>
+                <a:lumMod val="102000"/>
+              </a:schemeClr>
+            </a:gs>
+            <a:gs pos="50000">
+              <a:schemeClr val="phClr">
+                <a:tint val="98000"/>
+                <a:satMod val="130000"/>
+                <a:shade val="90000"/>
+                <a:lumMod val="103000"/>
+              </a:schemeClr>
+            </a:gs>
+            <a:gs pos="100000">
+              <a:schemeClr val="phClr">
+                <a:shade val="63000"/>
+                <a:satMod val="120000"/>
+              </a:schemeClr>
+            </a:gs>
+          </a:gsLst>
+          <a:lin ang="5400000" scaled="0"/>
+        </a:gradFill>
+      </a:bgFillStyleLst>
+    </a:fmtScheme>
+  </a:themeElements>
+  <a:objectDefaults>
+    <a:lnDef>
+      <a:spPr/>
+      <a:bodyPr/>
+      <a:lstStyle/>
+      <a:style>
+        <a:lnRef idx="2">
+          <a:schemeClr val="accent1"/>
+        </a:lnRef>
+        <a:fillRef idx="0">
+          <a:schemeClr val="accent1"/>
+        </a:fillRef>
+        <a:effectRef idx="1">
+          <a:schemeClr val="accent1"/>
+        </a:effectRef>
+        <a:fontRef idx="minor">
+          <a:schemeClr val="tx1"/>
+        </a:fontRef>
+      </a:style>
+    </a:lnDef>
+  </a:objectDefaults>
+  <a:extraClrSchemeLst/>
+  <a:extLst>
+    <a:ext uri="{05A4C25C-085E-4340-85A3-A5531E510DB2}">
+      <thm15:themeFamily xmlns:thm15="http://schemas.microsoft.com/office/thememl/2012/main" name="Office Theme" id="{2E142A2C-CD16-42D6-873A-C26D2A0506FA}" vid="{1BDDFF52-6CD6-40A5-AB3C-68EB2F1E4D0A}"/>
+    </a:ext>
+  </a:extLst>
+</a:theme>
 </file>
</xml_diff>

<commit_message>
delete fill_between -> solo fine slide
</commit_message>
<xml_diff>
--- a/the_shape_of_music.pptx
+++ b/the_shape_of_music.pptx
@@ -300,7 +300,15 @@
           <a:p>
             <a:r>
               <a:rPr lang="en-US" dirty="0"/>
-              <a:t>Aprire con la domanda narrativa: se potessimo ascoltare un decennio in pochi secondi, come suonerebbe? Il titolo rimanda sia alla forma visiva dei grafici — line plot, parallel coordinates — che al profilo sonoro di ogni epoca. Il dataset Kaggle di Yamac Eren Ay e tra i rari con 100 anni di copertura e feature audio normalizzate dall'API Spotify.</a:t>
+              <a:t>Aprire con la domanda narrativa: se potessimo ascoltare un decennio in pochi secondi, come </a:t>
+            </a:r>
+            <a:r>
+              <a:rPr lang="en-US" dirty="0" err="1"/>
+              <a:t>suonerebbe</a:t>
+            </a:r>
+            <a:r>
+              <a:rPr lang="en-US" dirty="0"/>
+              <a:t>?. Il dataset Kaggle di Yamac Eren Ay e tra i rari con 100 anni di copertura e feature audio normalizzate dall'API Spotify.</a:t>
             </a:r>
           </a:p>
         </p:txBody>
@@ -1165,9 +1173,538 @@
           <a:bodyPr/>
           <a:lstStyle/>
           <a:p>
-            <a:r>
-              <a:rPr lang="en-US" dirty="0"/>
-              <a:t>Risponde alla criticità del Nested Model (Munzner). WHY = perché visualizzare → gli obiettivi analitici. WHAT = cosa visualizzare → tipo di attributi nei dati. HOW = come visualizzare → la scelta dell'idiom visivo. Ogni livello ha le sue minacce alla validità: spiegare brevemente.</a:t>
+            <a:pPr lvl="0"/>
+            <a:r>
+              <a:rPr lang="it-IT" sz="1200" b="1" kern="1200" dirty="0">
+                <a:solidFill>
+                  <a:schemeClr val="tx1"/>
+                </a:solidFill>
+                <a:effectLst/>
+                <a:latin typeface="+mn-lt"/>
+                <a:ea typeface="+mn-ea"/>
+                <a:cs typeface="+mn-cs"/>
+              </a:rPr>
+              <a:t>Architettura del progetto su 3 pilastri metodologici:</a:t>
+            </a:r>
+          </a:p>
+          <a:p>
+            <a:pPr lvl="0"/>
+            <a:endParaRPr lang="it-IT" sz="1200" b="1" kern="1200" dirty="0">
+              <a:solidFill>
+                <a:schemeClr val="tx1"/>
+              </a:solidFill>
+              <a:effectLst/>
+              <a:latin typeface="+mn-lt"/>
+              <a:ea typeface="+mn-ea"/>
+              <a:cs typeface="+mn-cs"/>
+            </a:endParaRPr>
+          </a:p>
+          <a:p>
+            <a:pPr lvl="0"/>
+            <a:r>
+              <a:rPr lang="it-IT" sz="1200" b="1" kern="1200" dirty="0">
+                <a:solidFill>
+                  <a:schemeClr val="tx1"/>
+                </a:solidFill>
+                <a:effectLst/>
+                <a:latin typeface="+mn-lt"/>
+                <a:ea typeface="+mn-ea"/>
+                <a:cs typeface="+mn-cs"/>
+              </a:rPr>
+              <a:t>1) </a:t>
+            </a:r>
+            <a:r>
+              <a:rPr lang="it-IT" sz="1200" b="1" kern="1200" dirty="0" err="1">
+                <a:solidFill>
+                  <a:schemeClr val="tx1"/>
+                </a:solidFill>
+                <a:effectLst/>
+                <a:latin typeface="+mn-lt"/>
+                <a:ea typeface="+mn-ea"/>
+                <a:cs typeface="+mn-cs"/>
+              </a:rPr>
+              <a:t>Nested</a:t>
+            </a:r>
+            <a:r>
+              <a:rPr lang="it-IT" sz="1200" b="1" kern="1200" dirty="0">
+                <a:solidFill>
+                  <a:schemeClr val="tx1"/>
+                </a:solidFill>
+                <a:effectLst/>
+                <a:latin typeface="+mn-lt"/>
+                <a:ea typeface="+mn-ea"/>
+                <a:cs typeface="+mn-cs"/>
+              </a:rPr>
+              <a:t> Model (Tamara </a:t>
+            </a:r>
+            <a:r>
+              <a:rPr lang="it-IT" sz="1200" b="1" kern="1200" dirty="0" err="1">
+                <a:solidFill>
+                  <a:schemeClr val="tx1"/>
+                </a:solidFill>
+                <a:effectLst/>
+                <a:latin typeface="+mn-lt"/>
+                <a:ea typeface="+mn-ea"/>
+                <a:cs typeface="+mn-cs"/>
+              </a:rPr>
+              <a:t>Munzner</a:t>
+            </a:r>
+            <a:r>
+              <a:rPr lang="it-IT" sz="1200" b="1" kern="1200" dirty="0">
+                <a:solidFill>
+                  <a:schemeClr val="tx1"/>
+                </a:solidFill>
+                <a:effectLst/>
+                <a:latin typeface="+mn-lt"/>
+                <a:ea typeface="+mn-ea"/>
+                <a:cs typeface="+mn-cs"/>
+              </a:rPr>
+              <a:t>):</a:t>
+            </a:r>
+            <a:r>
+              <a:rPr lang="it-IT" sz="1200" kern="1200" dirty="0">
+                <a:solidFill>
+                  <a:schemeClr val="tx1"/>
+                </a:solidFill>
+                <a:effectLst/>
+                <a:latin typeface="+mn-lt"/>
+                <a:ea typeface="+mn-ea"/>
+                <a:cs typeface="+mn-cs"/>
+              </a:rPr>
+              <a:t> Il progetto è validato su 4 livelli (prevenire errori a cascata)</a:t>
+            </a:r>
+          </a:p>
+          <a:p>
+            <a:pPr lvl="1"/>
+            <a:r>
+              <a:rPr lang="it-IT" sz="1200" i="1" kern="1200" dirty="0">
+                <a:solidFill>
+                  <a:schemeClr val="tx1"/>
+                </a:solidFill>
+                <a:effectLst/>
+                <a:latin typeface="+mn-lt"/>
+                <a:ea typeface="+mn-ea"/>
+                <a:cs typeface="+mn-cs"/>
+              </a:rPr>
+              <a:t>A) Domain </a:t>
+            </a:r>
+            <a:r>
+              <a:rPr lang="it-IT" sz="1200" i="1" kern="1200" dirty="0" err="1">
+                <a:solidFill>
+                  <a:schemeClr val="tx1"/>
+                </a:solidFill>
+                <a:effectLst/>
+                <a:latin typeface="+mn-lt"/>
+                <a:ea typeface="+mn-ea"/>
+                <a:cs typeface="+mn-cs"/>
+              </a:rPr>
+              <a:t>Characterization</a:t>
+            </a:r>
+            <a:r>
+              <a:rPr lang="it-IT" sz="1200" i="1" kern="1200" dirty="0">
+                <a:solidFill>
+                  <a:schemeClr val="tx1"/>
+                </a:solidFill>
+                <a:effectLst/>
+                <a:latin typeface="+mn-lt"/>
+                <a:ea typeface="+mn-ea"/>
+                <a:cs typeface="+mn-cs"/>
+              </a:rPr>
+              <a:t>:</a:t>
+            </a:r>
+            <a:r>
+              <a:rPr lang="it-IT" sz="1200" kern="1200" dirty="0">
+                <a:solidFill>
+                  <a:schemeClr val="tx1"/>
+                </a:solidFill>
+                <a:effectLst/>
+                <a:latin typeface="+mn-lt"/>
+                <a:ea typeface="+mn-ea"/>
+                <a:cs typeface="+mn-cs"/>
+              </a:rPr>
+              <a:t> Come suona un decennio? L'evoluzione della hit commerciale.</a:t>
+            </a:r>
+          </a:p>
+          <a:p>
+            <a:pPr lvl="1"/>
+            <a:r>
+              <a:rPr lang="it-IT" sz="1200" b="1" i="1" kern="1200" dirty="0">
+                <a:solidFill>
+                  <a:schemeClr val="tx1"/>
+                </a:solidFill>
+                <a:effectLst/>
+                <a:latin typeface="+mn-lt"/>
+                <a:ea typeface="+mn-ea"/>
+                <a:cs typeface="+mn-cs"/>
+              </a:rPr>
+              <a:t>B) Data/Task </a:t>
+            </a:r>
+            <a:r>
+              <a:rPr lang="it-IT" sz="1200" b="1" i="1" kern="1200" dirty="0" err="1">
+                <a:solidFill>
+                  <a:schemeClr val="tx1"/>
+                </a:solidFill>
+                <a:effectLst/>
+                <a:latin typeface="+mn-lt"/>
+                <a:ea typeface="+mn-ea"/>
+                <a:cs typeface="+mn-cs"/>
+              </a:rPr>
+              <a:t>Abstraction</a:t>
+            </a:r>
+            <a:r>
+              <a:rPr lang="it-IT" sz="1200" i="1" kern="1200" dirty="0">
+                <a:solidFill>
+                  <a:schemeClr val="tx1"/>
+                </a:solidFill>
+                <a:effectLst/>
+                <a:latin typeface="+mn-lt"/>
+                <a:ea typeface="+mn-ea"/>
+                <a:cs typeface="+mn-cs"/>
+              </a:rPr>
+              <a:t>:</a:t>
+            </a:r>
+            <a:r>
+              <a:rPr lang="it-IT" sz="1200" kern="1200" dirty="0">
+                <a:solidFill>
+                  <a:schemeClr val="tx1"/>
+                </a:solidFill>
+                <a:effectLst/>
+                <a:latin typeface="+mn-lt"/>
+                <a:ea typeface="+mn-ea"/>
+                <a:cs typeface="+mn-cs"/>
+              </a:rPr>
+              <a:t> </a:t>
+            </a:r>
+          </a:p>
+          <a:p>
+            <a:pPr lvl="1"/>
+            <a:r>
+              <a:rPr lang="it-IT" sz="1200" kern="1200" dirty="0">
+                <a:solidFill>
+                  <a:schemeClr val="tx1"/>
+                </a:solidFill>
+                <a:effectLst/>
+                <a:latin typeface="+mn-lt"/>
+                <a:ea typeface="+mn-ea"/>
+                <a:cs typeface="+mn-cs"/>
+              </a:rPr>
+              <a:t>	-</a:t>
+            </a:r>
+            <a:r>
+              <a:rPr lang="it-IT" dirty="0"/>
+              <a:t> </a:t>
+            </a:r>
+            <a:r>
+              <a:rPr lang="it-IT" i="1" dirty="0" err="1"/>
+              <a:t>What</a:t>
+            </a:r>
+            <a:r>
+              <a:rPr lang="it-IT" dirty="0"/>
+              <a:t> (serie storiche, attributi quantitativi e strutture gerarchiche)</a:t>
+            </a:r>
+          </a:p>
+          <a:p>
+            <a:pPr lvl="1"/>
+            <a:r>
+              <a:rPr lang="it-IT" i="1" dirty="0"/>
+              <a:t>	-Why</a:t>
+            </a:r>
+            <a:r>
+              <a:rPr lang="it-IT" dirty="0"/>
+              <a:t>, declinato nelle azioni analitiche di </a:t>
+            </a:r>
+            <a:r>
+              <a:rPr lang="it-IT" i="1" dirty="0" err="1"/>
+              <a:t>Discover</a:t>
+            </a:r>
+            <a:r>
+              <a:rPr lang="it-IT" dirty="0"/>
+              <a:t> dei trend, </a:t>
+            </a:r>
+            <a:r>
+              <a:rPr lang="it-IT" i="1" dirty="0"/>
+              <a:t>Compare</a:t>
+            </a:r>
+            <a:r>
+              <a:rPr lang="it-IT" dirty="0"/>
+              <a:t> dei generi e </a:t>
+            </a:r>
+            <a:r>
+              <a:rPr lang="it-IT" i="1" dirty="0" err="1"/>
+              <a:t>Verify</a:t>
+            </a:r>
+            <a:r>
+              <a:rPr lang="it-IT" dirty="0"/>
+              <a:t> delle ipotesi 		predittive. </a:t>
+            </a:r>
+          </a:p>
+          <a:p>
+            <a:pPr lvl="1"/>
+            <a:r>
+              <a:rPr lang="it-IT" dirty="0"/>
+              <a:t>	-Questa astrazione vincola rigorosamente il </a:t>
+            </a:r>
+            <a:r>
+              <a:rPr lang="it-IT" i="1" dirty="0"/>
+              <a:t>Visual </a:t>
+            </a:r>
+            <a:r>
+              <a:rPr lang="it-IT" i="1" dirty="0" err="1"/>
+              <a:t>Encoding</a:t>
+            </a:r>
+            <a:r>
+              <a:rPr lang="it-IT" i="1" dirty="0"/>
+              <a:t> (How)</a:t>
+            </a:r>
+            <a:r>
+              <a:rPr lang="it-IT" dirty="0"/>
+              <a:t> e l'</a:t>
+            </a:r>
+            <a:r>
+              <a:rPr lang="it-IT" i="1" dirty="0" err="1"/>
+              <a:t>Algorithmic</a:t>
+            </a:r>
+            <a:r>
+              <a:rPr lang="it-IT" i="1" dirty="0"/>
+              <a:t> Design</a:t>
+            </a:r>
+            <a:r>
+              <a:rPr lang="it-IT" dirty="0"/>
+              <a:t>.</a:t>
+            </a:r>
+            <a:endParaRPr lang="it-IT" sz="1200" kern="1200" dirty="0">
+              <a:solidFill>
+                <a:schemeClr val="tx1"/>
+              </a:solidFill>
+              <a:effectLst/>
+              <a:latin typeface="+mn-lt"/>
+              <a:ea typeface="+mn-ea"/>
+              <a:cs typeface="+mn-cs"/>
+            </a:endParaRPr>
+          </a:p>
+          <a:p>
+            <a:pPr lvl="1"/>
+            <a:endParaRPr lang="it-IT" sz="1200" i="1" kern="1200" dirty="0">
+              <a:solidFill>
+                <a:schemeClr val="tx1"/>
+              </a:solidFill>
+              <a:effectLst/>
+              <a:latin typeface="+mn-lt"/>
+              <a:ea typeface="+mn-ea"/>
+              <a:cs typeface="+mn-cs"/>
+            </a:endParaRPr>
+          </a:p>
+          <a:p>
+            <a:pPr lvl="1"/>
+            <a:endParaRPr lang="it-IT" sz="1200" i="1" kern="1200" dirty="0">
+              <a:solidFill>
+                <a:schemeClr val="tx1"/>
+              </a:solidFill>
+              <a:effectLst/>
+              <a:latin typeface="+mn-lt"/>
+              <a:ea typeface="+mn-ea"/>
+              <a:cs typeface="+mn-cs"/>
+            </a:endParaRPr>
+          </a:p>
+          <a:p>
+            <a:pPr lvl="1"/>
+            <a:r>
+              <a:rPr lang="it-IT" sz="1200" i="1" kern="1200" dirty="0">
+                <a:solidFill>
+                  <a:schemeClr val="tx1"/>
+                </a:solidFill>
+                <a:effectLst/>
+                <a:latin typeface="+mn-lt"/>
+                <a:ea typeface="+mn-ea"/>
+                <a:cs typeface="+mn-cs"/>
+              </a:rPr>
+              <a:t>C) Visual </a:t>
+            </a:r>
+            <a:r>
+              <a:rPr lang="it-IT" sz="1200" i="1" kern="1200" dirty="0" err="1">
+                <a:solidFill>
+                  <a:schemeClr val="tx1"/>
+                </a:solidFill>
+                <a:effectLst/>
+                <a:latin typeface="+mn-lt"/>
+                <a:ea typeface="+mn-ea"/>
+                <a:cs typeface="+mn-cs"/>
+              </a:rPr>
+              <a:t>Encoding</a:t>
+            </a:r>
+            <a:r>
+              <a:rPr lang="it-IT" sz="1200" i="1" kern="1200" dirty="0">
+                <a:solidFill>
+                  <a:schemeClr val="tx1"/>
+                </a:solidFill>
+                <a:effectLst/>
+                <a:latin typeface="+mn-lt"/>
+                <a:ea typeface="+mn-ea"/>
+                <a:cs typeface="+mn-cs"/>
+              </a:rPr>
+              <a:t>/Interaction:</a:t>
+            </a:r>
+            <a:r>
+              <a:rPr lang="it-IT" sz="1200" kern="1200" dirty="0">
+                <a:solidFill>
+                  <a:schemeClr val="tx1"/>
+                </a:solidFill>
+                <a:effectLst/>
+                <a:latin typeface="+mn-lt"/>
+                <a:ea typeface="+mn-ea"/>
+                <a:cs typeface="+mn-cs"/>
+              </a:rPr>
+              <a:t> Scelte visive basate su Tufte, Gestalt e Ware.</a:t>
+            </a:r>
+          </a:p>
+          <a:p>
+            <a:pPr lvl="1"/>
+            <a:r>
+              <a:rPr lang="it-IT" sz="1200" i="1" kern="1200" dirty="0">
+                <a:solidFill>
+                  <a:schemeClr val="tx1"/>
+                </a:solidFill>
+                <a:effectLst/>
+                <a:latin typeface="+mn-lt"/>
+                <a:ea typeface="+mn-ea"/>
+                <a:cs typeface="+mn-cs"/>
+              </a:rPr>
+              <a:t>D) </a:t>
+            </a:r>
+            <a:r>
+              <a:rPr lang="it-IT" sz="1200" i="1" kern="1200" dirty="0" err="1">
+                <a:solidFill>
+                  <a:schemeClr val="tx1"/>
+                </a:solidFill>
+                <a:effectLst/>
+                <a:latin typeface="+mn-lt"/>
+                <a:ea typeface="+mn-ea"/>
+                <a:cs typeface="+mn-cs"/>
+              </a:rPr>
+              <a:t>Algorithmic</a:t>
+            </a:r>
+            <a:r>
+              <a:rPr lang="it-IT" sz="1200" i="1" kern="1200" dirty="0">
+                <a:solidFill>
+                  <a:schemeClr val="tx1"/>
+                </a:solidFill>
+                <a:effectLst/>
+                <a:latin typeface="+mn-lt"/>
+                <a:ea typeface="+mn-ea"/>
+                <a:cs typeface="+mn-cs"/>
+              </a:rPr>
+              <a:t> Design:</a:t>
+            </a:r>
+            <a:r>
+              <a:rPr lang="it-IT" sz="1200" kern="1200" dirty="0">
+                <a:solidFill>
+                  <a:schemeClr val="tx1"/>
+                </a:solidFill>
+                <a:effectLst/>
+                <a:latin typeface="+mn-lt"/>
+                <a:ea typeface="+mn-ea"/>
+                <a:cs typeface="+mn-cs"/>
+              </a:rPr>
+              <a:t> Elaborazione in Python/</a:t>
+            </a:r>
+            <a:r>
+              <a:rPr lang="it-IT" sz="1200" kern="1200" dirty="0" err="1">
+                <a:solidFill>
+                  <a:schemeClr val="tx1"/>
+                </a:solidFill>
+                <a:effectLst/>
+                <a:latin typeface="+mn-lt"/>
+                <a:ea typeface="+mn-ea"/>
+                <a:cs typeface="+mn-cs"/>
+              </a:rPr>
+              <a:t>Pandas</a:t>
+            </a:r>
+            <a:r>
+              <a:rPr lang="it-IT" sz="1200" kern="1200" dirty="0">
+                <a:solidFill>
+                  <a:schemeClr val="tx1"/>
+                </a:solidFill>
+                <a:effectLst/>
+                <a:latin typeface="+mn-lt"/>
+                <a:ea typeface="+mn-ea"/>
+                <a:cs typeface="+mn-cs"/>
+              </a:rPr>
+              <a:t> e </a:t>
+            </a:r>
+            <a:r>
+              <a:rPr lang="it-IT" sz="1200" kern="1200" dirty="0" err="1">
+                <a:solidFill>
+                  <a:schemeClr val="tx1"/>
+                </a:solidFill>
+                <a:effectLst/>
+                <a:latin typeface="+mn-lt"/>
+                <a:ea typeface="+mn-ea"/>
+                <a:cs typeface="+mn-cs"/>
+              </a:rPr>
+              <a:t>Decision</a:t>
+            </a:r>
+            <a:r>
+              <a:rPr lang="it-IT" sz="1200" kern="1200" dirty="0">
+                <a:solidFill>
+                  <a:schemeClr val="tx1"/>
+                </a:solidFill>
+                <a:effectLst/>
+                <a:latin typeface="+mn-lt"/>
+                <a:ea typeface="+mn-ea"/>
+                <a:cs typeface="+mn-cs"/>
+              </a:rPr>
+              <a:t> Tree (Scikit-Learn).</a:t>
+            </a:r>
+          </a:p>
+          <a:p>
+            <a:pPr lvl="1"/>
+            <a:endParaRPr lang="it-IT" sz="1200" kern="1200" dirty="0">
+              <a:solidFill>
+                <a:schemeClr val="tx1"/>
+              </a:solidFill>
+              <a:effectLst/>
+              <a:latin typeface="+mn-lt"/>
+              <a:ea typeface="+mn-ea"/>
+              <a:cs typeface="+mn-cs"/>
+            </a:endParaRPr>
+          </a:p>
+          <a:p>
+            <a:pPr lvl="1"/>
+            <a:endParaRPr lang="it-IT" sz="1200" kern="1200" dirty="0">
+              <a:solidFill>
+                <a:schemeClr val="tx1"/>
+              </a:solidFill>
+              <a:effectLst/>
+              <a:latin typeface="+mn-lt"/>
+              <a:ea typeface="+mn-ea"/>
+              <a:cs typeface="+mn-cs"/>
+            </a:endParaRPr>
+          </a:p>
+          <a:p>
+            <a:pPr lvl="1"/>
+            <a:endParaRPr lang="it-IT" sz="1200" kern="1200" dirty="0">
+              <a:solidFill>
+                <a:schemeClr val="tx1"/>
+              </a:solidFill>
+              <a:effectLst/>
+              <a:latin typeface="+mn-lt"/>
+              <a:ea typeface="+mn-ea"/>
+              <a:cs typeface="+mn-cs"/>
+            </a:endParaRPr>
+          </a:p>
+          <a:p>
+            <a:pPr lvl="1"/>
+            <a:r>
+              <a:rPr lang="it-IT" sz="1200" kern="1200" dirty="0">
+                <a:solidFill>
+                  <a:schemeClr val="tx1"/>
+                </a:solidFill>
+                <a:effectLst/>
+                <a:latin typeface="+mn-lt"/>
+                <a:ea typeface="+mn-ea"/>
+                <a:cs typeface="+mn-cs"/>
+              </a:rPr>
+              <a:t>Visual Analytics Process (Keim)</a:t>
             </a:r>
           </a:p>
         </p:txBody>
@@ -1253,9 +1790,151 @@
           <a:lstStyle/>
           <a:p>
             <a:r>
+              <a:rPr lang="it-IT" dirty="0"/>
+              <a:t>Nel primo modulo relativo alla </a:t>
+            </a:r>
+            <a:r>
+              <a:rPr lang="it-IT" b="1" dirty="0"/>
+              <a:t>Data Quality</a:t>
+            </a:r>
+            <a:r>
+              <a:rPr lang="it-IT" dirty="0"/>
+              <a:t>, applichiamo i canoni di Stephen Few per il Tabular Design. La tabella non è un </a:t>
+            </a:r>
+            <a:r>
+              <a:rPr lang="it-IT" u="sng" dirty="0"/>
+              <a:t>mero elemento testuale</a:t>
+            </a:r>
+            <a:r>
+              <a:rPr lang="it-IT" dirty="0"/>
+              <a:t>, ma un idioma di </a:t>
+            </a:r>
+            <a:r>
+              <a:rPr lang="it-IT" b="1" dirty="0"/>
+              <a:t>visualizzazione quantitativa</a:t>
+            </a:r>
+            <a:r>
+              <a:rPr lang="it-IT" dirty="0"/>
+              <a:t>. </a:t>
+            </a:r>
+          </a:p>
+          <a:p>
+            <a:r>
+              <a:rPr lang="en-US" dirty="0">
+                <a:sym typeface="Wingdings" pitchFamily="2" charset="2"/>
+              </a:rPr>
+              <a:t> </a:t>
+            </a:r>
+            <a:r>
+              <a:rPr lang="en-US" dirty="0" err="1"/>
+              <a:t>strumento</a:t>
+            </a:r>
+            <a:r>
               <a:rPr lang="en-US" dirty="0"/>
-              <a:t>La tabella Tab.1 (da mostrare in backup) applica Few: solo le misure necessarie, niente decorazione. La colonna null_% è evidenziata solo dove &gt; 0 (ombreggiatura come segnale, non come ornamento). Il grafico mostra la distribuzione dei macro-generi estratti da artists.csv: citare la presenza di 'Other' e motivarla.</a:t>
-            </a:r>
+              <a:t> </a:t>
+            </a:r>
+            <a:r>
+              <a:rPr lang="en-US" dirty="0" err="1"/>
+              <a:t>d’elezione</a:t>
+            </a:r>
+            <a:r>
+              <a:rPr lang="en-US" dirty="0"/>
+              <a:t> </a:t>
+            </a:r>
+            <a:r>
+              <a:rPr lang="en-US" dirty="0" err="1"/>
+              <a:t>quando</a:t>
+            </a:r>
+            <a:r>
+              <a:rPr lang="en-US" dirty="0"/>
+              <a:t> </a:t>
+            </a:r>
+            <a:r>
+              <a:rPr lang="en-US" dirty="0" err="1"/>
+              <a:t>l’utente</a:t>
+            </a:r>
+            <a:r>
+              <a:rPr lang="en-US" dirty="0"/>
+              <a:t> </a:t>
+            </a:r>
+            <a:r>
+              <a:rPr lang="en-US" dirty="0" err="1"/>
+              <a:t>deve</a:t>
+            </a:r>
+            <a:r>
+              <a:rPr lang="en-US" dirty="0"/>
+              <a:t> </a:t>
+            </a:r>
+            <a:r>
+              <a:rPr lang="en-US" b="1" dirty="0" err="1"/>
+              <a:t>effettuare</a:t>
+            </a:r>
+            <a:r>
+              <a:rPr lang="en-US" b="1" dirty="0"/>
+              <a:t> un look-up di </a:t>
+            </a:r>
+            <a:r>
+              <a:rPr lang="en-US" b="1" dirty="0" err="1"/>
+              <a:t>valori</a:t>
+            </a:r>
+            <a:r>
+              <a:rPr lang="en-US" b="1" dirty="0"/>
+              <a:t> </a:t>
+            </a:r>
+            <a:r>
+              <a:rPr lang="en-US" b="1" dirty="0" err="1"/>
+              <a:t>precisi</a:t>
+            </a:r>
+            <a:r>
+              <a:rPr lang="en-US" dirty="0"/>
+              <a:t> o </a:t>
+            </a:r>
+            <a:r>
+              <a:rPr lang="en-US" dirty="0" err="1"/>
+              <a:t>quando</a:t>
+            </a:r>
+            <a:r>
+              <a:rPr lang="en-US" dirty="0"/>
+              <a:t> ci </a:t>
+            </a:r>
+            <a:r>
+              <a:rPr lang="en-US" dirty="0" err="1"/>
+              <a:t>sono</a:t>
+            </a:r>
+            <a:r>
+              <a:rPr lang="en-US" dirty="0"/>
+              <a:t> </a:t>
+            </a:r>
+            <a:r>
+              <a:rPr lang="en-US" b="1" dirty="0" err="1"/>
+              <a:t>unitá</a:t>
+            </a:r>
+            <a:r>
+              <a:rPr lang="en-US" b="1" dirty="0"/>
+              <a:t> di </a:t>
+            </a:r>
+            <a:r>
+              <a:rPr lang="en-US" b="1" dirty="0" err="1"/>
+              <a:t>misura</a:t>
+            </a:r>
+            <a:r>
+              <a:rPr lang="en-US" b="1" dirty="0"/>
+              <a:t> diverse</a:t>
+            </a:r>
+            <a:endParaRPr lang="it-IT" dirty="0"/>
+          </a:p>
+          <a:p>
+            <a:endParaRPr lang="it-IT" dirty="0"/>
+          </a:p>
+          <a:p>
+            <a:endParaRPr lang="it-IT" dirty="0"/>
+          </a:p>
+          <a:p>
+            <a:r>
+              <a:rPr lang="it-IT" dirty="0"/>
+              <a:t>Abbiamo massimizzato il Data-Ink Ratio (Tufte) eliminando le linee di griglia interne ed evitando l'effetto Moiré. L'allineamento a destra dei valori numerici permette alla memoria iconica di confrontare istantaneamente gli ordini di grandezza. Il Lie Factor è mantenuto rigorosamente pari a 1 grazie alla normalizzazione Min-Max delle feature acustiche, garantendo l'integrità grafica prescritta da Edward Tufte.</a:t>
+            </a:r>
+            <a:endParaRPr lang="en-US" dirty="0"/>
           </a:p>
         </p:txBody>
       </p:sp>
@@ -6431,7 +7110,10 @@
             <a:r>
               <a:rPr lang="en-US" sz="1000" i="1" dirty="0">
                 <a:solidFill>
-                  <a:srgbClr val="BF5200"/>
+                  <a:schemeClr val="tx1">
+                    <a:lumMod val="50000"/>
+                    <a:lumOff val="50000"/>
+                  </a:schemeClr>
                 </a:solidFill>
                 <a:latin typeface="Calibri" pitchFamily="34" charset="0"/>
                 <a:ea typeface="Calibri" pitchFamily="34" charset="-122"/>
@@ -6439,7 +7121,14 @@
               </a:rPr>
               <a:t>Munzner (2014) · Nested Model of Visualization Design</a:t>
             </a:r>
-            <a:endParaRPr lang="en-US" sz="1000" dirty="0"/>
+            <a:endParaRPr lang="en-US" sz="1000" dirty="0">
+              <a:solidFill>
+                <a:schemeClr val="tx1">
+                  <a:lumMod val="50000"/>
+                  <a:lumOff val="50000"/>
+                </a:schemeClr>
+              </a:solidFill>
+            </a:endParaRPr>
           </a:p>
         </p:txBody>
       </p:sp>
@@ -6451,8 +7140,8 @@
         </p:nvSpPr>
         <p:spPr>
           <a:xfrm>
-            <a:off x="411480" y="1188720"/>
-            <a:ext cx="2788920" cy="3611880"/>
+            <a:off x="3182823" y="1709225"/>
+            <a:ext cx="2788920" cy="2482945"/>
           </a:xfrm>
           <a:prstGeom prst="roundRect">
             <a:avLst>
@@ -6460,11 +7149,14 @@
             </a:avLst>
           </a:prstGeom>
           <a:solidFill>
-            <a:srgbClr val="E6F1FB"/>
+            <a:schemeClr val="accent4">
+              <a:lumMod val="20000"/>
+              <a:lumOff val="80000"/>
+            </a:schemeClr>
           </a:solidFill>
           <a:ln w="6350">
             <a:solidFill>
-              <a:srgbClr val="185FA5"/>
+              <a:schemeClr val="accent4"/>
             </a:solidFill>
             <a:prstDash val="solid"/>
           </a:ln>
@@ -6480,7 +7172,9 @@
           <a:bodyPr/>
           <a:lstStyle/>
           <a:p>
-            <a:endParaRPr lang="it-IT"/>
+            <a:endParaRPr lang="it-IT" b="1">
+              <a:latin typeface="Aptos Display" panose="020B0004020202020204" pitchFamily="34" charset="0"/>
+            </a:endParaRPr>
           </a:p>
         </p:txBody>
       </p:sp>
@@ -6492,7 +7186,7 @@
         </p:nvSpPr>
         <p:spPr>
           <a:xfrm>
-            <a:off x="548640" y="1325880"/>
+            <a:off x="3319983" y="1846385"/>
             <a:ext cx="2514600" cy="457200"/>
           </a:xfrm>
           <a:prstGeom prst="rect">
@@ -6509,17 +7203,16 @@
               <a:buNone/>
             </a:pPr>
             <a:r>
-              <a:rPr lang="en-US" sz="2000" b="1" dirty="0">
-                <a:solidFill>
-                  <a:srgbClr val="0C447C"/>
-                </a:solidFill>
-                <a:latin typeface="Cambria" pitchFamily="34" charset="0"/>
+              <a:rPr lang="en-US" sz="2400" b="1" dirty="0">
+                <a:latin typeface="Aptos Display" panose="020B0004020202020204" pitchFamily="34" charset="0"/>
                 <a:ea typeface="Cambria" pitchFamily="34" charset="-122"/>
                 <a:cs typeface="Cambria" pitchFamily="34" charset="-120"/>
               </a:rPr>
               <a:t>WHY</a:t>
             </a:r>
-            <a:endParaRPr lang="en-US" sz="2000" dirty="0"/>
+            <a:endParaRPr lang="en-US" sz="2400" b="1" dirty="0">
+              <a:latin typeface="Aptos Display" panose="020B0004020202020204" pitchFamily="34" charset="0"/>
+            </a:endParaRPr>
           </a:p>
         </p:txBody>
       </p:sp>
@@ -6531,7 +7224,7 @@
         </p:nvSpPr>
         <p:spPr>
           <a:xfrm>
-            <a:off x="548640" y="1755648"/>
+            <a:off x="3334051" y="2276153"/>
             <a:ext cx="2514600" cy="274320"/>
           </a:xfrm>
           <a:prstGeom prst="rect">
@@ -6548,17 +7241,16 @@
               <a:buNone/>
             </a:pPr>
             <a:r>
-              <a:rPr lang="en-US" sz="1000" i="1" dirty="0">
-                <a:solidFill>
-                  <a:srgbClr val="0C447C"/>
-                </a:solidFill>
-                <a:latin typeface="Calibri" pitchFamily="34" charset="0"/>
+              <a:rPr lang="en-US" sz="1050" b="1" dirty="0">
+                <a:latin typeface="Aptos Display" panose="020B0004020202020204" pitchFamily="34" charset="0"/>
                 <a:ea typeface="Calibri" pitchFamily="34" charset="-122"/>
                 <a:cs typeface="Calibri" pitchFamily="34" charset="-120"/>
               </a:rPr>
               <a:t>Obiettivi analitici</a:t>
             </a:r>
-            <a:endParaRPr lang="en-US" sz="1000" dirty="0"/>
+            <a:endParaRPr lang="en-US" sz="1050" b="1" dirty="0">
+              <a:latin typeface="Aptos Display" panose="020B0004020202020204" pitchFamily="34" charset="0"/>
+            </a:endParaRPr>
           </a:p>
         </p:txBody>
       </p:sp>
@@ -6570,7 +7262,7 @@
         </p:nvSpPr>
         <p:spPr>
           <a:xfrm>
-            <a:off x="548640" y="2148840"/>
+            <a:off x="3319983" y="2669345"/>
             <a:ext cx="2514600" cy="2468880"/>
           </a:xfrm>
           <a:prstGeom prst="rect">
@@ -6588,17 +7280,16 @@
               <a:buChar char="•"/>
             </a:pPr>
             <a:r>
-              <a:rPr lang="en-US" sz="1200" dirty="0">
-                <a:solidFill>
-                  <a:srgbClr val="0C447C"/>
-                </a:solidFill>
-                <a:latin typeface="Calibri" pitchFamily="34" charset="0"/>
+              <a:rPr lang="en-US" sz="1400" b="1" dirty="0">
+                <a:latin typeface="Aptos Display" panose="020B0004020202020204" pitchFamily="34" charset="0"/>
                 <a:ea typeface="Calibri" pitchFamily="34" charset="-122"/>
                 <a:cs typeface="Calibri" pitchFamily="34" charset="-120"/>
               </a:rPr>
               <a:t>Discover trend temporali</a:t>
             </a:r>
-            <a:endParaRPr lang="en-US" sz="1200" dirty="0"/>
+            <a:endParaRPr lang="en-US" sz="1400" b="1" dirty="0">
+              <a:latin typeface="Aptos Display" panose="020B0004020202020204" pitchFamily="34" charset="0"/>
+            </a:endParaRPr>
           </a:p>
           <a:p>
             <a:pPr marL="342900" indent="-342900">
@@ -6606,17 +7297,16 @@
               <a:buChar char="•"/>
             </a:pPr>
             <a:r>
-              <a:rPr lang="en-US" sz="1200" dirty="0">
-                <a:solidFill>
-                  <a:srgbClr val="0C447C"/>
-                </a:solidFill>
-                <a:latin typeface="Calibri" pitchFamily="34" charset="0"/>
+              <a:rPr lang="en-US" sz="1400" b="1" dirty="0">
+                <a:latin typeface="Aptos Display" panose="020B0004020202020204" pitchFamily="34" charset="0"/>
                 <a:ea typeface="Calibri" pitchFamily="34" charset="-122"/>
                 <a:cs typeface="Calibri" pitchFamily="34" charset="-120"/>
               </a:rPr>
               <a:t>Compare generi musicali</a:t>
             </a:r>
-            <a:endParaRPr lang="en-US" sz="1200" dirty="0"/>
+            <a:endParaRPr lang="en-US" sz="1400" b="1" dirty="0">
+              <a:latin typeface="Aptos Display" panose="020B0004020202020204" pitchFamily="34" charset="0"/>
+            </a:endParaRPr>
           </a:p>
           <a:p>
             <a:pPr marL="342900" indent="-342900">
@@ -6624,17 +7314,16 @@
               <a:buChar char="•"/>
             </a:pPr>
             <a:r>
-              <a:rPr lang="en-US" sz="1200" dirty="0">
-                <a:solidFill>
-                  <a:srgbClr val="0C447C"/>
-                </a:solidFill>
-                <a:latin typeface="Calibri" pitchFamily="34" charset="0"/>
+              <a:rPr lang="en-US" sz="1400" b="1" dirty="0">
+                <a:latin typeface="Aptos Display" panose="020B0004020202020204" pitchFamily="34" charset="0"/>
                 <a:ea typeface="Calibri" pitchFamily="34" charset="-122"/>
                 <a:cs typeface="Calibri" pitchFamily="34" charset="-120"/>
               </a:rPr>
               <a:t>Verify: hit → feature audio</a:t>
             </a:r>
-            <a:endParaRPr lang="en-US" sz="1200" dirty="0"/>
+            <a:endParaRPr lang="en-US" sz="1400" b="1" dirty="0">
+              <a:latin typeface="Aptos Display" panose="020B0004020202020204" pitchFamily="34" charset="0"/>
+            </a:endParaRPr>
           </a:p>
         </p:txBody>
       </p:sp>
@@ -6646,8 +7335,8 @@
         </p:nvSpPr>
         <p:spPr>
           <a:xfrm>
-            <a:off x="3337560" y="1188720"/>
-            <a:ext cx="2788920" cy="3611880"/>
+            <a:off x="87925" y="1723290"/>
+            <a:ext cx="2788920" cy="2468880"/>
           </a:xfrm>
           <a:prstGeom prst="roundRect">
             <a:avLst>
@@ -6655,11 +7344,11 @@
             </a:avLst>
           </a:prstGeom>
           <a:solidFill>
-            <a:srgbClr val="E1F5EE"/>
+            <a:srgbClr val="F3C9CB"/>
           </a:solidFill>
           <a:ln w="6350">
             <a:solidFill>
-              <a:srgbClr val="1D9E75"/>
+              <a:srgbClr val="FF0000"/>
             </a:solidFill>
             <a:prstDash val="solid"/>
           </a:ln>
@@ -6675,7 +7364,9 @@
           <a:bodyPr/>
           <a:lstStyle/>
           <a:p>
-            <a:endParaRPr lang="it-IT"/>
+            <a:endParaRPr lang="it-IT" b="1">
+              <a:latin typeface="Aptos Display" panose="020B0004020202020204" pitchFamily="34" charset="0"/>
+            </a:endParaRPr>
           </a:p>
         </p:txBody>
       </p:sp>
@@ -6687,7 +7378,7 @@
         </p:nvSpPr>
         <p:spPr>
           <a:xfrm>
-            <a:off x="3474720" y="1325880"/>
+            <a:off x="225085" y="1860450"/>
             <a:ext cx="2514600" cy="457200"/>
           </a:xfrm>
           <a:prstGeom prst="rect">
@@ -6704,17 +7395,16 @@
               <a:buNone/>
             </a:pPr>
             <a:r>
-              <a:rPr lang="en-US" sz="2000" b="1" dirty="0">
-                <a:solidFill>
-                  <a:srgbClr val="085041"/>
-                </a:solidFill>
-                <a:latin typeface="Cambria" pitchFamily="34" charset="0"/>
+              <a:rPr lang="en-US" sz="2400" b="1" dirty="0">
+                <a:latin typeface="Aptos Display" panose="020B0004020202020204" pitchFamily="34" charset="0"/>
                 <a:ea typeface="Cambria" pitchFamily="34" charset="-122"/>
                 <a:cs typeface="Cambria" pitchFamily="34" charset="-120"/>
               </a:rPr>
               <a:t>WHAT</a:t>
             </a:r>
-            <a:endParaRPr lang="en-US" sz="2000" dirty="0"/>
+            <a:endParaRPr lang="en-US" sz="2400" b="1" dirty="0">
+              <a:latin typeface="Aptos Display" panose="020B0004020202020204" pitchFamily="34" charset="0"/>
+            </a:endParaRPr>
           </a:p>
         </p:txBody>
       </p:sp>
@@ -6726,7 +7416,7 @@
         </p:nvSpPr>
         <p:spPr>
           <a:xfrm>
-            <a:off x="3474720" y="1755648"/>
+            <a:off x="253221" y="2290218"/>
             <a:ext cx="2514600" cy="274320"/>
           </a:xfrm>
           <a:prstGeom prst="rect">
@@ -6743,17 +7433,16 @@
               <a:buNone/>
             </a:pPr>
             <a:r>
-              <a:rPr lang="en-US" sz="1000" i="1" dirty="0">
-                <a:solidFill>
-                  <a:srgbClr val="085041"/>
-                </a:solidFill>
-                <a:latin typeface="Calibri" pitchFamily="34" charset="0"/>
+              <a:rPr lang="en-US" sz="1050" b="1" dirty="0">
+                <a:latin typeface="Aptos Display" panose="020B0004020202020204" pitchFamily="34" charset="0"/>
                 <a:ea typeface="Calibri" pitchFamily="34" charset="-122"/>
                 <a:cs typeface="Calibri" pitchFamily="34" charset="-120"/>
               </a:rPr>
               <a:t>Tipo di dati</a:t>
             </a:r>
-            <a:endParaRPr lang="en-US" sz="1000" dirty="0"/>
+            <a:endParaRPr lang="en-US" sz="1050" b="1" dirty="0">
+              <a:latin typeface="Aptos Display" panose="020B0004020202020204" pitchFamily="34" charset="0"/>
+            </a:endParaRPr>
           </a:p>
         </p:txBody>
       </p:sp>
@@ -6765,7 +7454,7 @@
         </p:nvSpPr>
         <p:spPr>
           <a:xfrm>
-            <a:off x="3474720" y="2148840"/>
+            <a:off x="225085" y="2683410"/>
             <a:ext cx="2514600" cy="2468880"/>
           </a:xfrm>
           <a:prstGeom prst="rect">
@@ -6783,17 +7472,16 @@
               <a:buChar char="•"/>
             </a:pPr>
             <a:r>
-              <a:rPr lang="en-US" sz="1200" dirty="0">
-                <a:solidFill>
-                  <a:srgbClr val="085041"/>
-                </a:solidFill>
-                <a:latin typeface="Calibri" pitchFamily="34" charset="0"/>
+              <a:rPr lang="en-US" sz="1400" b="1" dirty="0">
+                <a:latin typeface="Aptos Display" panose="020B0004020202020204" pitchFamily="34" charset="0"/>
                 <a:ea typeface="Calibri" pitchFamily="34" charset="-122"/>
                 <a:cs typeface="Calibri" pitchFamily="34" charset="-120"/>
               </a:rPr>
               <a:t>Time-series quantitative (10 feature audio)</a:t>
             </a:r>
-            <a:endParaRPr lang="en-US" sz="1200" dirty="0"/>
+            <a:endParaRPr lang="en-US" sz="1400" b="1" dirty="0">
+              <a:latin typeface="Aptos Display" panose="020B0004020202020204" pitchFamily="34" charset="0"/>
+            </a:endParaRPr>
           </a:p>
           <a:p>
             <a:pPr marL="342900" indent="-342900">
@@ -6801,17 +7489,16 @@
               <a:buChar char="•"/>
             </a:pPr>
             <a:r>
-              <a:rPr lang="en-US" sz="1200" dirty="0">
-                <a:solidFill>
-                  <a:srgbClr val="085041"/>
-                </a:solidFill>
-                <a:latin typeface="Calibri" pitchFamily="34" charset="0"/>
+              <a:rPr lang="en-US" sz="1400" b="1" dirty="0">
+                <a:latin typeface="Aptos Display" panose="020B0004020202020204" pitchFamily="34" charset="0"/>
                 <a:ea typeface="Calibri" pitchFamily="34" charset="-122"/>
                 <a:cs typeface="Calibri" pitchFamily="34" charset="-120"/>
               </a:rPr>
               <a:t>Dati categorici (generi)</a:t>
             </a:r>
-            <a:endParaRPr lang="en-US" sz="1200" dirty="0"/>
+            <a:endParaRPr lang="en-US" sz="1400" b="1" dirty="0">
+              <a:latin typeface="Aptos Display" panose="020B0004020202020204" pitchFamily="34" charset="0"/>
+            </a:endParaRPr>
           </a:p>
           <a:p>
             <a:pPr marL="342900" indent="-342900">
@@ -6819,17 +7506,16 @@
               <a:buChar char="•"/>
             </a:pPr>
             <a:r>
-              <a:rPr lang="en-US" sz="1200" dirty="0">
-                <a:solidFill>
-                  <a:srgbClr val="085041"/>
-                </a:solidFill>
-                <a:latin typeface="Calibri" pitchFamily="34" charset="0"/>
+              <a:rPr lang="en-US" sz="1400" b="1" dirty="0">
+                <a:latin typeface="Aptos Display" panose="020B0004020202020204" pitchFamily="34" charset="0"/>
                 <a:ea typeface="Calibri" pitchFamily="34" charset="-122"/>
                 <a:cs typeface="Calibri" pitchFamily="34" charset="-120"/>
               </a:rPr>
               <a:t>Struttura ad albero (DT)</a:t>
             </a:r>
-            <a:endParaRPr lang="en-US" sz="1200" dirty="0"/>
+            <a:endParaRPr lang="en-US" sz="1400" b="1" dirty="0">
+              <a:latin typeface="Aptos Display" panose="020B0004020202020204" pitchFamily="34" charset="0"/>
+            </a:endParaRPr>
           </a:p>
         </p:txBody>
       </p:sp>
@@ -6841,8 +7527,8 @@
         </p:nvSpPr>
         <p:spPr>
           <a:xfrm>
-            <a:off x="6263640" y="1188720"/>
-            <a:ext cx="2788920" cy="3611880"/>
+            <a:off x="6263640" y="1709225"/>
+            <a:ext cx="2788920" cy="2482945"/>
           </a:xfrm>
           <a:prstGeom prst="roundRect">
             <a:avLst>
@@ -6850,11 +7536,14 @@
             </a:avLst>
           </a:prstGeom>
           <a:solidFill>
-            <a:srgbClr val="FAEEDA"/>
+            <a:schemeClr val="accent6">
+              <a:lumMod val="20000"/>
+              <a:lumOff val="80000"/>
+            </a:schemeClr>
           </a:solidFill>
           <a:ln w="6350">
             <a:solidFill>
-              <a:srgbClr val="BF5200"/>
+              <a:schemeClr val="accent6"/>
             </a:solidFill>
             <a:prstDash val="solid"/>
           </a:ln>
@@ -6882,7 +7571,7 @@
         </p:nvSpPr>
         <p:spPr>
           <a:xfrm>
-            <a:off x="6400800" y="1325880"/>
+            <a:off x="6400800" y="1846385"/>
             <a:ext cx="2514600" cy="457200"/>
           </a:xfrm>
           <a:prstGeom prst="rect">
@@ -6899,17 +7588,16 @@
               <a:buNone/>
             </a:pPr>
             <a:r>
-              <a:rPr lang="en-US" sz="2000" b="1" dirty="0">
-                <a:solidFill>
-                  <a:srgbClr val="633806"/>
-                </a:solidFill>
-                <a:latin typeface="Cambria" pitchFamily="34" charset="0"/>
+              <a:rPr lang="en-US" sz="2400" b="1" dirty="0">
+                <a:latin typeface="Aptos Display" panose="020B0004020202020204" pitchFamily="34" charset="0"/>
                 <a:ea typeface="Cambria" pitchFamily="34" charset="-122"/>
                 <a:cs typeface="Cambria" pitchFamily="34" charset="-120"/>
               </a:rPr>
               <a:t>HOW</a:t>
             </a:r>
-            <a:endParaRPr lang="en-US" sz="2000" dirty="0"/>
+            <a:endParaRPr lang="en-US" sz="2400" b="1" dirty="0">
+              <a:latin typeface="Aptos Display" panose="020B0004020202020204" pitchFamily="34" charset="0"/>
+            </a:endParaRPr>
           </a:p>
         </p:txBody>
       </p:sp>
@@ -6921,7 +7609,7 @@
         </p:nvSpPr>
         <p:spPr>
           <a:xfrm>
-            <a:off x="6400800" y="1755648"/>
+            <a:off x="6414868" y="2276153"/>
             <a:ext cx="2514600" cy="274320"/>
           </a:xfrm>
           <a:prstGeom prst="rect">
@@ -6938,17 +7626,16 @@
               <a:buNone/>
             </a:pPr>
             <a:r>
-              <a:rPr lang="en-US" sz="1000" i="1" dirty="0">
-                <a:solidFill>
-                  <a:srgbClr val="633806"/>
-                </a:solidFill>
-                <a:latin typeface="Calibri" pitchFamily="34" charset="0"/>
+              <a:rPr lang="en-US" sz="1050" b="1" dirty="0">
+                <a:latin typeface="Aptos Display" panose="020B0004020202020204" pitchFamily="34" charset="0"/>
                 <a:ea typeface="Calibri" pitchFamily="34" charset="-122"/>
                 <a:cs typeface="Calibri" pitchFamily="34" charset="-120"/>
               </a:rPr>
               <a:t>Idiom visivo</a:t>
             </a:r>
-            <a:endParaRPr lang="en-US" sz="1000" dirty="0"/>
+            <a:endParaRPr lang="en-US" sz="1050" b="1" dirty="0">
+              <a:latin typeface="Aptos Display" panose="020B0004020202020204" pitchFamily="34" charset="0"/>
+            </a:endParaRPr>
           </a:p>
         </p:txBody>
       </p:sp>
@@ -6960,8 +7647,8 @@
         </p:nvSpPr>
         <p:spPr>
           <a:xfrm>
-            <a:off x="6400800" y="2148840"/>
-            <a:ext cx="2514600" cy="2468880"/>
+            <a:off x="6400800" y="2669345"/>
+            <a:ext cx="2514600" cy="1171135"/>
           </a:xfrm>
           <a:prstGeom prst="rect">
             <a:avLst/>
@@ -6978,17 +7665,16 @@
               <a:buChar char="•"/>
             </a:pPr>
             <a:r>
-              <a:rPr lang="en-US" sz="1200" dirty="0">
-                <a:solidFill>
-                  <a:srgbClr val="633806"/>
-                </a:solidFill>
-                <a:latin typeface="Calibri" pitchFamily="34" charset="0"/>
+              <a:rPr lang="en-US" sz="1400" b="1" dirty="0">
+                <a:latin typeface="Aptos Display" panose="020B0004020202020204" pitchFamily="34" charset="0"/>
                 <a:ea typeface="Calibri" pitchFamily="34" charset="-122"/>
                 <a:cs typeface="Calibri" pitchFamily="34" charset="-120"/>
               </a:rPr>
               <a:t>Line marks + Small Multiples (M2, M3)</a:t>
             </a:r>
-            <a:endParaRPr lang="en-US" sz="1200" dirty="0"/>
+            <a:endParaRPr lang="en-US" sz="1400" b="1" dirty="0">
+              <a:latin typeface="Aptos Display" panose="020B0004020202020204" pitchFamily="34" charset="0"/>
+            </a:endParaRPr>
           </a:p>
           <a:p>
             <a:pPr marL="342900" indent="-342900">
@@ -6996,17 +7682,16 @@
               <a:buChar char="•"/>
             </a:pPr>
             <a:r>
-              <a:rPr lang="en-US" sz="1200" dirty="0">
-                <a:solidFill>
-                  <a:srgbClr val="633806"/>
-                </a:solidFill>
-                <a:latin typeface="Calibri" pitchFamily="34" charset="0"/>
+              <a:rPr lang="en-US" sz="1400" b="1" dirty="0">
+                <a:latin typeface="Aptos Display" panose="020B0004020202020204" pitchFamily="34" charset="0"/>
                 <a:ea typeface="Calibri" pitchFamily="34" charset="-122"/>
                 <a:cs typeface="Calibri" pitchFamily="34" charset="-120"/>
               </a:rPr>
               <a:t>Parallel Coordinates (M4)</a:t>
             </a:r>
-            <a:endParaRPr lang="en-US" sz="1200" dirty="0"/>
+            <a:endParaRPr lang="en-US" sz="1400" b="1" dirty="0">
+              <a:latin typeface="Aptos Display" panose="020B0004020202020204" pitchFamily="34" charset="0"/>
+            </a:endParaRPr>
           </a:p>
           <a:p>
             <a:pPr marL="342900" indent="-342900">
@@ -7014,17 +7699,16 @@
               <a:buChar char="•"/>
             </a:pPr>
             <a:r>
-              <a:rPr lang="en-US" sz="1200" dirty="0">
-                <a:solidFill>
-                  <a:srgbClr val="633806"/>
-                </a:solidFill>
-                <a:latin typeface="Calibri" pitchFamily="34" charset="0"/>
+              <a:rPr lang="en-US" sz="1400" b="1" dirty="0">
+                <a:latin typeface="Aptos Display" panose="020B0004020202020204" pitchFamily="34" charset="0"/>
                 <a:ea typeface="Calibri" pitchFamily="34" charset="-122"/>
                 <a:cs typeface="Calibri" pitchFamily="34" charset="-120"/>
               </a:rPr>
               <a:t>Node-link diagram (M5)</a:t>
             </a:r>
-            <a:endParaRPr lang="en-US" sz="1200" dirty="0"/>
+            <a:endParaRPr lang="en-US" sz="1400" b="1" dirty="0">
+              <a:latin typeface="Aptos Display" panose="020B0004020202020204" pitchFamily="34" charset="0"/>
+            </a:endParaRPr>
           </a:p>
         </p:txBody>
       </p:sp>
@@ -7182,7 +7866,7 @@
         <p:spPr>
           <a:xfrm>
             <a:off x="411480" y="1097280"/>
-            <a:ext cx="3566160" cy="987552"/>
+            <a:ext cx="1920240" cy="987552"/>
           </a:xfrm>
           <a:prstGeom prst="roundRect">
             <a:avLst>
@@ -7261,7 +7945,7 @@
         </p:nvSpPr>
         <p:spPr>
           <a:xfrm>
-            <a:off x="2011680" y="1280160"/>
+            <a:off x="502920" y="1503836"/>
             <a:ext cx="1828800" cy="594360"/>
           </a:xfrm>
           <a:prstGeom prst="rect">
@@ -7301,7 +7985,7 @@
         <p:spPr>
           <a:xfrm>
             <a:off x="411480" y="2267712"/>
-            <a:ext cx="3566160" cy="987552"/>
+            <a:ext cx="1920240" cy="987552"/>
           </a:xfrm>
           <a:prstGeom prst="roundRect">
             <a:avLst>
@@ -7380,7 +8064,7 @@
         </p:nvSpPr>
         <p:spPr>
           <a:xfrm>
-            <a:off x="2011680" y="2450592"/>
+            <a:off x="502920" y="2677082"/>
             <a:ext cx="1828800" cy="594360"/>
           </a:xfrm>
           <a:prstGeom prst="rect">
@@ -7420,7 +8104,7 @@
         <p:spPr>
           <a:xfrm>
             <a:off x="411480" y="3438144"/>
-            <a:ext cx="3566160" cy="987552"/>
+            <a:ext cx="1920240" cy="987552"/>
           </a:xfrm>
           <a:prstGeom prst="roundRect">
             <a:avLst>
@@ -7499,7 +8183,7 @@
         </p:nvSpPr>
         <p:spPr>
           <a:xfrm>
-            <a:off x="2011680" y="3621024"/>
+            <a:off x="502920" y="3861580"/>
             <a:ext cx="1828800" cy="594360"/>
           </a:xfrm>
           <a:prstGeom prst="rect">
@@ -7532,55 +8216,14 @@
       </p:sp>
       <p:sp>
         <p:nvSpPr>
-          <p:cNvPr id="14" name="Shape 12"/>
-          <p:cNvSpPr/>
-          <p:nvPr/>
-        </p:nvSpPr>
-        <p:spPr>
-          <a:xfrm>
-            <a:off x="4251960" y="1051560"/>
-            <a:ext cx="4572000" cy="3520440"/>
-          </a:xfrm>
-          <a:prstGeom prst="roundRect">
-            <a:avLst>
-              <a:gd name="adj" fmla="val 2078"/>
-            </a:avLst>
-          </a:prstGeom>
-          <a:solidFill>
-            <a:srgbClr val="F1EFE8"/>
-          </a:solidFill>
-          <a:ln w="6350">
-            <a:solidFill>
-              <a:srgbClr val="D3D1C7"/>
-            </a:solidFill>
-            <a:prstDash val="solid"/>
-          </a:ln>
-          <a:effectLst>
-            <a:outerShdw blurRad="63500" dist="25400" dir="2700000" algn="bl" rotWithShape="0">
-              <a:srgbClr val="000000">
-                <a:alpha val="8000"/>
-              </a:srgbClr>
-            </a:outerShdw>
-          </a:effectLst>
-        </p:spPr>
-        <p:txBody>
-          <a:bodyPr/>
-          <a:lstStyle/>
-          <a:p>
-            <a:endParaRPr lang="it-IT"/>
-          </a:p>
-        </p:txBody>
-      </p:sp>
-      <p:sp>
-        <p:nvSpPr>
-          <p:cNvPr id="15" name="Text 13"/>
-          <p:cNvSpPr/>
-          <p:nvPr/>
-        </p:nvSpPr>
-        <p:spPr>
-          <a:xfrm>
-            <a:off x="4251960" y="2583180"/>
-            <a:ext cx="4572000" cy="457200"/>
+          <p:cNvPr id="16" name="Text 14"/>
+          <p:cNvSpPr/>
+          <p:nvPr/>
+        </p:nvSpPr>
+        <p:spPr>
+          <a:xfrm>
+            <a:off x="411480" y="4709160"/>
+            <a:ext cx="8321040" cy="320040"/>
           </a:xfrm>
           <a:prstGeom prst="rect">
             <a:avLst/>
@@ -7592,77 +8235,110 @@
           <a:bodyPr wrap="square" rtlCol="0" anchor="ctr"/>
           <a:lstStyle/>
           <a:p>
-            <a:pPr marL="0" indent="0" algn="ctr">
+            <a:pPr marL="0" indent="0" algn="l">
               <a:buNone/>
             </a:pPr>
             <a:r>
-              <a:rPr lang="en-US" sz="1000" b="1" dirty="0">
-                <a:solidFill>
-                  <a:srgbClr val="B4B2A9"/>
+              <a:rPr lang="en-US" sz="950" i="1" strike="sngStrike" dirty="0">
+                <a:solidFill>
+                  <a:srgbClr val="FF0000"/>
                 </a:solidFill>
                 <a:latin typeface="Calibri" pitchFamily="34" charset="0"/>
                 <a:ea typeface="Calibri" pitchFamily="34" charset="-122"/>
                 <a:cs typeface="Calibri" pitchFamily="34" charset="-120"/>
               </a:rPr>
-              <a:t>m1_genre_distribution.png</a:t>
-            </a:r>
-            <a:endParaRPr lang="en-US" sz="1000" dirty="0"/>
-          </a:p>
-          <a:p>
-            <a:pPr marL="0" indent="0" algn="ctr">
-              <a:buNone/>
-            </a:pPr>
-            <a:r>
-              <a:rPr lang="en-US" sz="1000" i="1" dirty="0">
-                <a:solidFill>
-                  <a:srgbClr val="B4B2A9"/>
-                </a:solidFill>
-                <a:latin typeface="Calibri" pitchFamily="34" charset="0"/>
-                <a:ea typeface="Calibri" pitchFamily="34" charset="-122"/>
-                <a:cs typeface="Calibri" pitchFamily="34" charset="-120"/>
-              </a:rPr>
-              <a:t>→ inserire output notebook</a:t>
-            </a:r>
-            <a:endParaRPr lang="en-US" sz="1000" dirty="0"/>
-          </a:p>
-        </p:txBody>
-      </p:sp>
-      <p:sp>
-        <p:nvSpPr>
-          <p:cNvPr id="16" name="Text 14"/>
-          <p:cNvSpPr/>
-          <p:nvPr/>
-        </p:nvSpPr>
-        <p:spPr>
-          <a:xfrm>
-            <a:off x="411480" y="4709160"/>
-            <a:ext cx="8321040" cy="320040"/>
+              <a:t>Stephen Few · Table Design: numeri allineati a destra, niente griglie interne · Lie Factor = 1</a:t>
+            </a:r>
+            <a:endParaRPr lang="en-US" sz="950" strike="sngStrike" dirty="0">
+              <a:solidFill>
+                <a:srgbClr val="FF0000"/>
+              </a:solidFill>
+            </a:endParaRPr>
+          </a:p>
+        </p:txBody>
+      </p:sp>
+      <p:pic>
+        <p:nvPicPr>
+          <p:cNvPr id="18" name="Immagine 17">
+            <a:extLst>
+              <a:ext uri="{FF2B5EF4-FFF2-40B4-BE49-F238E27FC236}">
+                <a16:creationId xmlns:a16="http://schemas.microsoft.com/office/drawing/2014/main" id="{68E01972-880F-2377-176C-C1AB5279F34B}"/>
+              </a:ext>
+            </a:extLst>
+          </p:cNvPr>
+          <p:cNvPicPr>
+            <a:picLocks noChangeAspect="1"/>
+          </p:cNvPicPr>
+          <p:nvPr/>
+        </p:nvPicPr>
+        <p:blipFill>
+          <a:blip r:embed="rId3"/>
+          <a:stretch>
+            <a:fillRect/>
+          </a:stretch>
+        </p:blipFill>
+        <p:spPr>
+          <a:xfrm>
+            <a:off x="2581129" y="1350500"/>
+            <a:ext cx="6151391" cy="3013435"/>
           </a:xfrm>
           <a:prstGeom prst="rect">
             <a:avLst/>
           </a:prstGeom>
+        </p:spPr>
+      </p:pic>
+      <p:sp>
+        <p:nvSpPr>
+          <p:cNvPr id="19" name="CasellaDiTesto 18">
+            <a:extLst>
+              <a:ext uri="{FF2B5EF4-FFF2-40B4-BE49-F238E27FC236}">
+                <a16:creationId xmlns:a16="http://schemas.microsoft.com/office/drawing/2014/main" id="{301732D5-D595-0DE9-AF95-2BAB5A665C88}"/>
+              </a:ext>
+            </a:extLst>
+          </p:cNvPr>
+          <p:cNvSpPr txBox="1"/>
+          <p:nvPr/>
+        </p:nvSpPr>
+        <p:spPr>
+          <a:xfrm>
+            <a:off x="4839287" y="4271694"/>
+            <a:ext cx="4473526" cy="646331"/>
+          </a:xfrm>
+          <a:prstGeom prst="rect">
+            <a:avLst/>
+          </a:prstGeom>
           <a:noFill/>
-          <a:ln/>
-        </p:spPr>
-        <p:txBody>
-          <a:bodyPr wrap="square" rtlCol="0" anchor="ctr"/>
-          <a:lstStyle/>
-          <a:p>
-            <a:pPr marL="0" indent="0" algn="l">
-              <a:buNone/>
-            </a:pPr>
-            <a:r>
-              <a:rPr lang="en-US" sz="950" i="1" dirty="0">
-                <a:solidFill>
-                  <a:srgbClr val="B4B2A9"/>
-                </a:solidFill>
-                <a:latin typeface="Calibri" pitchFamily="34" charset="0"/>
-                <a:ea typeface="Calibri" pitchFamily="34" charset="-122"/>
-                <a:cs typeface="Calibri" pitchFamily="34" charset="-120"/>
-              </a:rPr>
-              <a:t>Stephen Few · Table Design: numeri allineati a destra, niente griglie interne · Lie Factor = 1</a:t>
-            </a:r>
-            <a:endParaRPr lang="en-US" sz="950" dirty="0"/>
+        </p:spPr>
+        <p:txBody>
+          <a:bodyPr wrap="square" rtlCol="0">
+            <a:spAutoFit/>
+          </a:bodyPr>
+          <a:lstStyle/>
+          <a:p>
+            <a:r>
+              <a:rPr lang="it-IT" dirty="0">
+                <a:solidFill>
+                  <a:srgbClr val="F610EB"/>
+                </a:solidFill>
+              </a:rPr>
+              <a:t>Massimizzato data-</a:t>
+            </a:r>
+            <a:r>
+              <a:rPr lang="it-IT" dirty="0" err="1">
+                <a:solidFill>
+                  <a:srgbClr val="F610EB"/>
+                </a:solidFill>
+              </a:rPr>
+              <a:t>ink</a:t>
+            </a:r>
+            <a:r>
+              <a:rPr lang="it-IT" dirty="0">
+                <a:solidFill>
+                  <a:srgbClr val="F610EB"/>
+                </a:solidFill>
+              </a:rPr>
+              <a:t> di Tufte e tolto Moiré???? Griglia c’è ancora!!!</a:t>
+            </a:r>
           </a:p>
         </p:txBody>
       </p:sp>

</xml_diff>